<commit_message>
Pivot session to Foundry Toolkit focus
Refocus the repo and talk assets for a simpler Foundry Toolkit for VS Code
session: rewrite README positioning, replace the 25-minute runbook with a
toolkit-only flow, and rebuild the slide generator/deck to match that scope.
Keep advanced multi-agent content in the repo as optional appendix material.

Co-authored-by: Copilot <223556219+Copilot@users.noreply.github.com>
</commit_message>
<xml_diff>
--- a/deck/Build2026-Recap-Agents.pptx
+++ b/deck/Build2026-Recap-Agents.pptx
@@ -18,12 +18,6 @@
     <p:sldId id="266" r:id="rId18"/>
     <p:sldId id="267" r:id="rId19"/>
     <p:sldId id="268" r:id="rId20"/>
-    <p:sldId id="269" r:id="rId21"/>
-    <p:sldId id="270" r:id="rId22"/>
-    <p:sldId id="271" r:id="rId23"/>
-    <p:sldId id="272" r:id="rId24"/>
-    <p:sldId id="273" r:id="rId25"/>
-    <p:sldId id="274" r:id="rId26"/>
   </p:sldIdLst>
   <p:sldSz cx="12192000" cy="6858000" type="screen4x3"/>
   <p:notesSz cx="6858000" cy="9144000"/>
@@ -520,612 +514,12 @@
           <a:lstStyle/>
           <a:p>
             <a:r>
-              <a:t>Welcome. Two shipping-now things that make agent dev faster:</a:t>
-            </a:r>
-          </a:p>
-          <a:p>
-            <a:r>
-              <a:t>1) Microsoft Agent Framework now has STABLE orchestration building blocks.</a:t>
-            </a:r>
-          </a:p>
-          <a:p>
-            <a:r>
-              <a:t>2) Foundry Toolkit for VS Code is GENERALLY AVAILABLE.</a:t>
-            </a:r>
-          </a:p>
-          <a:p>
-            <a:r>
-              <a:t>We'll cover what they are, then a live demo that uses both. ~25 minutes, code is on GitHub.</a:t>
-            </a:r>
-          </a:p>
-        </p:txBody>
-      </p:sp>
-      <p:sp>
-        <p:nvSpPr>
-          <p:cNvPr id="4" name="Slide Number Placeholder 3"/>
-          <p:cNvSpPr>
-            <a:spLocks noGrp="1"/>
-          </p:cNvSpPr>
-          <p:nvPr>
-            <p:ph type="sldNum" idx="5" sz="quarter"/>
-          </p:nvPr>
-        </p:nvSpPr>
-        <p:spPr/>
-      </p:sp>
-    </p:spTree>
-  </p:cSld>
-  <p:clrMapOvr>
-    <a:masterClrMapping/>
-  </p:clrMapOvr>
-</p:notes>
-</file>
-
-<file path=ppt/notesSlides/notesSlide10.xml><?xml version="1.0" encoding="utf-8"?>
-<p:notes xmlns:a="http://schemas.openxmlformats.org/drawingml/2006/main" xmlns:p="http://schemas.openxmlformats.org/presentationml/2006/main" xmlns:r="http://schemas.openxmlformats.org/officeDocument/2006/relationships">
-  <p:cSld>
-    <p:spTree>
-      <p:nvGrpSpPr>
-        <p:cNvPr id="1" name=""/>
-        <p:cNvGrpSpPr/>
-        <p:nvPr/>
-      </p:nvGrpSpPr>
-      <p:grpSpPr>
-        <a:xfrm>
-          <a:off x="0" y="0"/>
-          <a:ext cx="0" cy="0"/>
-          <a:chOff x="0" y="0"/>
-          <a:chExt cx="0" cy="0"/>
-        </a:xfrm>
-      </p:grpSpPr>
-      <p:sp>
-        <p:nvSpPr>
-          <p:cNvPr id="2" name="Slide Image Placeholder 1"/>
-          <p:cNvSpPr>
-            <a:spLocks noGrp="1"/>
-          </p:cNvSpPr>
-          <p:nvPr>
-            <p:ph type="sldImg" idx="2"/>
-          </p:nvPr>
-        </p:nvSpPr>
-        <p:spPr/>
-      </p:sp>
-      <p:sp>
-        <p:nvSpPr>
-          <p:cNvPr id="3" name="Notes Placeholder 2"/>
-          <p:cNvSpPr>
-            <a:spLocks noGrp="1"/>
-          </p:cNvSpPr>
-          <p:nvPr>
-            <p:ph type="body" idx="3" sz="quarter"/>
-          </p:nvPr>
-        </p:nvSpPr>
-        <p:spPr/>
-        <p:txBody>
-          <a:bodyPr/>
-          <a:lstStyle/>
-          <a:p>
-            <a:r>
-              <a:t>Group chat = brainstorm/debate; editor says 'SHIP IT' to stop.</a:t>
-            </a:r>
-          </a:p>
-          <a:p>
-            <a:r>
-              <a:t>Magentic = most autonomous: manager writes a plan, delegates, synthesizes. Bounded by max_* limits.</a:t>
-            </a:r>
-          </a:p>
-        </p:txBody>
-      </p:sp>
-      <p:sp>
-        <p:nvSpPr>
-          <p:cNvPr id="4" name="Slide Number Placeholder 3"/>
-          <p:cNvSpPr>
-            <a:spLocks noGrp="1"/>
-          </p:cNvSpPr>
-          <p:nvPr>
-            <p:ph type="sldNum" idx="5" sz="quarter"/>
-          </p:nvPr>
-        </p:nvSpPr>
-        <p:spPr/>
-      </p:sp>
-    </p:spTree>
-  </p:cSld>
-  <p:clrMapOvr>
-    <a:masterClrMapping/>
-  </p:clrMapOvr>
-</p:notes>
-</file>
-
-<file path=ppt/notesSlides/notesSlide11.xml><?xml version="1.0" encoding="utf-8"?>
-<p:notes xmlns:a="http://schemas.openxmlformats.org/drawingml/2006/main" xmlns:p="http://schemas.openxmlformats.org/presentationml/2006/main" xmlns:r="http://schemas.openxmlformats.org/officeDocument/2006/relationships">
-  <p:cSld>
-    <p:spTree>
-      <p:nvGrpSpPr>
-        <p:cNvPr id="1" name=""/>
-        <p:cNvGrpSpPr/>
-        <p:nvPr/>
-      </p:nvGrpSpPr>
-      <p:grpSpPr>
-        <a:xfrm>
-          <a:off x="0" y="0"/>
-          <a:ext cx="0" cy="0"/>
-          <a:chOff x="0" y="0"/>
-          <a:chExt cx="0" cy="0"/>
-        </a:xfrm>
-      </p:grpSpPr>
-      <p:sp>
-        <p:nvSpPr>
-          <p:cNvPr id="2" name="Slide Image Placeholder 1"/>
-          <p:cNvSpPr>
-            <a:spLocks noGrp="1"/>
-          </p:cNvSpPr>
-          <p:nvPr>
-            <p:ph type="sldImg" idx="2"/>
-          </p:nvPr>
-        </p:nvSpPr>
-        <p:spPr/>
-      </p:sp>
-      <p:sp>
-        <p:nvSpPr>
-          <p:cNvPr id="3" name="Notes Placeholder 2"/>
-          <p:cNvSpPr>
-            <a:spLocks noGrp="1"/>
-          </p:cNvSpPr>
-          <p:nvPr>
-            <p:ph type="body" idx="3" sz="quarter"/>
-          </p:nvPr>
-        </p:nvSpPr>
-        <p:spPr/>
-        <p:txBody>
-          <a:bodyPr/>
-          <a:lstStyle/>
-          <a:p>
-            <a:r>
-              <a:t>Enterprise story. Read-only tools run automatically; risky/write tools require approval.</a:t>
-            </a:r>
-          </a:p>
-          <a:p>
-            <a:r>
-              <a:t>Same primitive across all five patterns. This is the trust boundary for autonomous agents.</a:t>
-            </a:r>
-          </a:p>
-        </p:txBody>
-      </p:sp>
-      <p:sp>
-        <p:nvSpPr>
-          <p:cNvPr id="4" name="Slide Number Placeholder 3"/>
-          <p:cNvSpPr>
-            <a:spLocks noGrp="1"/>
-          </p:cNvSpPr>
-          <p:nvPr>
-            <p:ph type="sldNum" idx="5" sz="quarter"/>
-          </p:nvPr>
-        </p:nvSpPr>
-        <p:spPr/>
-      </p:sp>
-    </p:spTree>
-  </p:cSld>
-  <p:clrMapOvr>
-    <a:masterClrMapping/>
-  </p:clrMapOvr>
-</p:notes>
-</file>
-
-<file path=ppt/notesSlides/notesSlide12.xml><?xml version="1.0" encoding="utf-8"?>
-<p:notes xmlns:a="http://schemas.openxmlformats.org/drawingml/2006/main" xmlns:p="http://schemas.openxmlformats.org/presentationml/2006/main" xmlns:r="http://schemas.openxmlformats.org/officeDocument/2006/relationships">
-  <p:cSld>
-    <p:spTree>
-      <p:nvGrpSpPr>
-        <p:cNvPr id="1" name=""/>
-        <p:cNvGrpSpPr/>
-        <p:nvPr/>
-      </p:nvGrpSpPr>
-      <p:grpSpPr>
-        <a:xfrm>
-          <a:off x="0" y="0"/>
-          <a:ext cx="0" cy="0"/>
-          <a:chOff x="0" y="0"/>
-          <a:chExt cx="0" cy="0"/>
-        </a:xfrm>
-      </p:grpSpPr>
-      <p:sp>
-        <p:nvSpPr>
-          <p:cNvPr id="2" name="Slide Image Placeholder 1"/>
-          <p:cNvSpPr>
-            <a:spLocks noGrp="1"/>
-          </p:cNvSpPr>
-          <p:nvPr>
-            <p:ph type="sldImg" idx="2"/>
-          </p:nvPr>
-        </p:nvSpPr>
-        <p:spPr/>
-      </p:sp>
-      <p:sp>
-        <p:nvSpPr>
-          <p:cNvPr id="3" name="Notes Placeholder 2"/>
-          <p:cNvSpPr>
-            <a:spLocks noGrp="1"/>
-          </p:cNvSpPr>
-          <p:nvPr>
-            <p:ph type="body" idx="3" sz="quarter"/>
-          </p:nvPr>
-        </p:nvSpPr>
-        <p:spPr/>
-        <p:txBody>
-          <a:bodyPr/>
-          <a:lstStyle/>
-          <a:p>
-            <a:r>
-              <a:t>GA matters: supported, stable. It's the on-ramp. You don't provision cloud to start —</a:t>
-            </a:r>
-          </a:p>
-          <a:p>
-            <a:r>
-              <a:t>discover a model, test in Playground, build in Agent Builder, debug in Agent Inspector,</a:t>
-            </a:r>
-          </a:p>
-          <a:p>
-            <a:r>
-              <a:t>trace locally, evaluate, then deploy to Foundry Agent Service.</a:t>
-            </a:r>
-          </a:p>
-        </p:txBody>
-      </p:sp>
-      <p:sp>
-        <p:nvSpPr>
-          <p:cNvPr id="4" name="Slide Number Placeholder 3"/>
-          <p:cNvSpPr>
-            <a:spLocks noGrp="1"/>
-          </p:cNvSpPr>
-          <p:nvPr>
-            <p:ph type="sldNum" idx="5" sz="quarter"/>
-          </p:nvPr>
-        </p:nvSpPr>
-        <p:spPr/>
-      </p:sp>
-    </p:spTree>
-  </p:cSld>
-  <p:clrMapOvr>
-    <a:masterClrMapping/>
-  </p:clrMapOvr>
-</p:notes>
-</file>
-
-<file path=ppt/notesSlides/notesSlide13.xml><?xml version="1.0" encoding="utf-8"?>
-<p:notes xmlns:a="http://schemas.openxmlformats.org/drawingml/2006/main" xmlns:p="http://schemas.openxmlformats.org/presentationml/2006/main" xmlns:r="http://schemas.openxmlformats.org/officeDocument/2006/relationships">
-  <p:cSld>
-    <p:spTree>
-      <p:nvGrpSpPr>
-        <p:cNvPr id="1" name=""/>
-        <p:cNvGrpSpPr/>
-        <p:nvPr/>
-      </p:nvGrpSpPr>
-      <p:grpSpPr>
-        <a:xfrm>
-          <a:off x="0" y="0"/>
-          <a:ext cx="0" cy="0"/>
-          <a:chOff x="0" y="0"/>
-          <a:chExt cx="0" cy="0"/>
-        </a:xfrm>
-      </p:grpSpPr>
-      <p:sp>
-        <p:nvSpPr>
-          <p:cNvPr id="2" name="Slide Image Placeholder 1"/>
-          <p:cNvSpPr>
-            <a:spLocks noGrp="1"/>
-          </p:cNvSpPr>
-          <p:nvPr>
-            <p:ph type="sldImg" idx="2"/>
-          </p:nvPr>
-        </p:nvSpPr>
-        <p:spPr/>
-      </p:sp>
-      <p:sp>
-        <p:nvSpPr>
-          <p:cNvPr id="3" name="Notes Placeholder 2"/>
-          <p:cNvSpPr>
-            <a:spLocks noGrp="1"/>
-          </p:cNvSpPr>
-          <p:nvPr>
-            <p:ph type="body" idx="3" sz="quarter"/>
-          </p:nvPr>
-        </p:nvSpPr>
-        <p:spPr/>
-        <p:txBody>
-          <a:bodyPr/>
-          <a:lstStyle/>
-          <a:p>
-            <a:r>
-              <a:t>This is the 'got faster' thesis in one slide. The demo walks this loop.</a:t>
-            </a:r>
-          </a:p>
-        </p:txBody>
-      </p:sp>
-      <p:sp>
-        <p:nvSpPr>
-          <p:cNvPr id="4" name="Slide Number Placeholder 3"/>
-          <p:cNvSpPr>
-            <a:spLocks noGrp="1"/>
-          </p:cNvSpPr>
-          <p:nvPr>
-            <p:ph type="sldNum" idx="5" sz="quarter"/>
-          </p:nvPr>
-        </p:nvSpPr>
-        <p:spPr/>
-      </p:sp>
-    </p:spTree>
-  </p:cSld>
-  <p:clrMapOvr>
-    <a:masterClrMapping/>
-  </p:clrMapOvr>
-</p:notes>
-</file>
-
-<file path=ppt/notesSlides/notesSlide14.xml><?xml version="1.0" encoding="utf-8"?>
-<p:notes xmlns:a="http://schemas.openxmlformats.org/drawingml/2006/main" xmlns:p="http://schemas.openxmlformats.org/presentationml/2006/main" xmlns:r="http://schemas.openxmlformats.org/officeDocument/2006/relationships">
-  <p:cSld>
-    <p:spTree>
-      <p:nvGrpSpPr>
-        <p:cNvPr id="1" name=""/>
-        <p:cNvGrpSpPr/>
-        <p:nvPr/>
-      </p:nvGrpSpPr>
-      <p:grpSpPr>
-        <a:xfrm>
-          <a:off x="0" y="0"/>
-          <a:ext cx="0" cy="0"/>
-          <a:chOff x="0" y="0"/>
-          <a:chExt cx="0" cy="0"/>
-        </a:xfrm>
-      </p:grpSpPr>
-      <p:sp>
-        <p:nvSpPr>
-          <p:cNvPr id="2" name="Slide Image Placeholder 1"/>
-          <p:cNvSpPr>
-            <a:spLocks noGrp="1"/>
-          </p:cNvSpPr>
-          <p:nvPr>
-            <p:ph type="sldImg" idx="2"/>
-          </p:nvPr>
-        </p:nvSpPr>
-        <p:spPr/>
-      </p:sp>
-      <p:sp>
-        <p:nvSpPr>
-          <p:cNvPr id="3" name="Notes Placeholder 2"/>
-          <p:cNvSpPr>
-            <a:spLocks noGrp="1"/>
-          </p:cNvSpPr>
-          <p:nvPr>
-            <p:ph type="body" idx="3" sz="quarter"/>
-          </p:nvPr>
-        </p:nvSpPr>
-        <p:spPr/>
-        <p:txBody>
-          <a:bodyPr/>
-          <a:lstStyle/>
-          <a:p>
-            <a:r>
-              <a:t>DEMO. Follow docs/DEMO_SCRIPT.md. Order: 01 sequential, 02 concurrent, 03 handoff,</a:t>
-            </a:r>
-          </a:p>
-          <a:p>
-            <a:r>
-              <a:t>05 magentic, then 06 HITL for the 'wow'. Have Agent Inspector / Tracing open in VS Code.</a:t>
-            </a:r>
-          </a:p>
-          <a:p>
-            <a:r>
-              <a:t>Fallback: set MODEL_BACKEND=github if Azure/Wi-Fi misbehaves. Run `make smoke` beforehand.</a:t>
-            </a:r>
-          </a:p>
-        </p:txBody>
-      </p:sp>
-      <p:sp>
-        <p:nvSpPr>
-          <p:cNvPr id="4" name="Slide Number Placeholder 3"/>
-          <p:cNvSpPr>
-            <a:spLocks noGrp="1"/>
-          </p:cNvSpPr>
-          <p:nvPr>
-            <p:ph type="sldNum" idx="5" sz="quarter"/>
-          </p:nvPr>
-        </p:nvSpPr>
-        <p:spPr/>
-      </p:sp>
-    </p:spTree>
-  </p:cSld>
-  <p:clrMapOvr>
-    <a:masterClrMapping/>
-  </p:clrMapOvr>
-</p:notes>
-</file>
-
-<file path=ppt/notesSlides/notesSlide15.xml><?xml version="1.0" encoding="utf-8"?>
-<p:notes xmlns:a="http://schemas.openxmlformats.org/drawingml/2006/main" xmlns:p="http://schemas.openxmlformats.org/presentationml/2006/main" xmlns:r="http://schemas.openxmlformats.org/officeDocument/2006/relationships">
-  <p:cSld>
-    <p:spTree>
-      <p:nvGrpSpPr>
-        <p:cNvPr id="1" name=""/>
-        <p:cNvGrpSpPr/>
-        <p:nvPr/>
-      </p:nvGrpSpPr>
-      <p:grpSpPr>
-        <a:xfrm>
-          <a:off x="0" y="0"/>
-          <a:ext cx="0" cy="0"/>
-          <a:chOff x="0" y="0"/>
-          <a:chExt cx="0" cy="0"/>
-        </a:xfrm>
-      </p:grpSpPr>
-      <p:sp>
-        <p:nvSpPr>
-          <p:cNvPr id="2" name="Slide Image Placeholder 1"/>
-          <p:cNvSpPr>
-            <a:spLocks noGrp="1"/>
-          </p:cNvSpPr>
-          <p:nvPr>
-            <p:ph type="sldImg" idx="2"/>
-          </p:nvPr>
-        </p:nvSpPr>
-        <p:spPr/>
-      </p:sp>
-      <p:sp>
-        <p:nvSpPr>
-          <p:cNvPr id="3" name="Notes Placeholder 2"/>
-          <p:cNvSpPr>
-            <a:spLocks noGrp="1"/>
-          </p:cNvSpPr>
-          <p:nvPr>
-            <p:ph type="body" idx="3" sz="quarter"/>
-          </p:nvPr>
-        </p:nvSpPr>
-        <p:spPr/>
-        <p:txBody>
-          <a:bodyPr/>
-          <a:lstStyle/>
-          <a:p>
-            <a:r>
-              <a:t>The one-slide summary if you're short on time. Land the 'got faster' message.</a:t>
-            </a:r>
-          </a:p>
-        </p:txBody>
-      </p:sp>
-      <p:sp>
-        <p:nvSpPr>
-          <p:cNvPr id="4" name="Slide Number Placeholder 3"/>
-          <p:cNvSpPr>
-            <a:spLocks noGrp="1"/>
-          </p:cNvSpPr>
-          <p:nvPr>
-            <p:ph type="sldNum" idx="5" sz="quarter"/>
-          </p:nvPr>
-        </p:nvSpPr>
-        <p:spPr/>
-      </p:sp>
-    </p:spTree>
-  </p:cSld>
-  <p:clrMapOvr>
-    <a:masterClrMapping/>
-  </p:clrMapOvr>
-</p:notes>
-</file>
-
-<file path=ppt/notesSlides/notesSlide16.xml><?xml version="1.0" encoding="utf-8"?>
-<p:notes xmlns:a="http://schemas.openxmlformats.org/drawingml/2006/main" xmlns:p="http://schemas.openxmlformats.org/presentationml/2006/main" xmlns:r="http://schemas.openxmlformats.org/officeDocument/2006/relationships">
-  <p:cSld>
-    <p:spTree>
-      <p:nvGrpSpPr>
-        <p:cNvPr id="1" name=""/>
-        <p:cNvGrpSpPr/>
-        <p:nvPr/>
-      </p:nvGrpSpPr>
-      <p:grpSpPr>
-        <a:xfrm>
-          <a:off x="0" y="0"/>
-          <a:ext cx="0" cy="0"/>
-          <a:chOff x="0" y="0"/>
-          <a:chExt cx="0" cy="0"/>
-        </a:xfrm>
-      </p:grpSpPr>
-      <p:sp>
-        <p:nvSpPr>
-          <p:cNvPr id="2" name="Slide Image Placeholder 1"/>
-          <p:cNvSpPr>
-            <a:spLocks noGrp="1"/>
-          </p:cNvSpPr>
-          <p:nvPr>
-            <p:ph type="sldImg" idx="2"/>
-          </p:nvPr>
-        </p:nvSpPr>
-        <p:spPr/>
-      </p:sp>
-      <p:sp>
-        <p:nvSpPr>
-          <p:cNvPr id="3" name="Notes Placeholder 2"/>
-          <p:cNvSpPr>
-            <a:spLocks noGrp="1"/>
-          </p:cNvSpPr>
-          <p:nvPr>
-            <p:ph type="body" idx="3" sz="quarter"/>
-          </p:nvPr>
-        </p:nvSpPr>
-        <p:spPr/>
-        <p:txBody>
-          <a:bodyPr/>
-          <a:lstStyle/>
-          <a:p>
-            <a:r>
-              <a:t>Leave this up during Q&amp;A. Replace the repo URL with your GitHub link.</a:t>
-            </a:r>
-          </a:p>
-        </p:txBody>
-      </p:sp>
-      <p:sp>
-        <p:nvSpPr>
-          <p:cNvPr id="4" name="Slide Number Placeholder 3"/>
-          <p:cNvSpPr>
-            <a:spLocks noGrp="1"/>
-          </p:cNvSpPr>
-          <p:nvPr>
-            <p:ph type="sldNum" idx="5" sz="quarter"/>
-          </p:nvPr>
-        </p:nvSpPr>
-        <p:spPr/>
-      </p:sp>
-    </p:spTree>
-  </p:cSld>
-  <p:clrMapOvr>
-    <a:masterClrMapping/>
-  </p:clrMapOvr>
-</p:notes>
-</file>
-
-<file path=ppt/notesSlides/notesSlide17.xml><?xml version="1.0" encoding="utf-8"?>
-<p:notes xmlns:a="http://schemas.openxmlformats.org/drawingml/2006/main" xmlns:p="http://schemas.openxmlformats.org/presentationml/2006/main" xmlns:r="http://schemas.openxmlformats.org/officeDocument/2006/relationships">
-  <p:cSld>
-    <p:spTree>
-      <p:nvGrpSpPr>
-        <p:cNvPr id="1" name=""/>
-        <p:cNvGrpSpPr/>
-        <p:nvPr/>
-      </p:nvGrpSpPr>
-      <p:grpSpPr>
-        <a:xfrm>
-          <a:off x="0" y="0"/>
-          <a:ext cx="0" cy="0"/>
-          <a:chOff x="0" y="0"/>
-          <a:chExt cx="0" cy="0"/>
-        </a:xfrm>
-      </p:grpSpPr>
-      <p:sp>
-        <p:nvSpPr>
-          <p:cNvPr id="2" name="Slide Image Placeholder 1"/>
-          <p:cNvSpPr>
-            <a:spLocks noGrp="1"/>
-          </p:cNvSpPr>
-          <p:nvPr>
-            <p:ph type="sldImg" idx="2"/>
-          </p:nvPr>
-        </p:nvSpPr>
-        <p:spPr/>
-      </p:sp>
-      <p:sp>
-        <p:nvSpPr>
-          <p:cNvPr id="3" name="Notes Placeholder 2"/>
-          <p:cNvSpPr>
-            <a:spLocks noGrp="1"/>
-          </p:cNvSpPr>
-          <p:nvPr>
-            <p:ph type="body" idx="3" sz="quarter"/>
-          </p:nvPr>
-        </p:nvSpPr>
-        <p:spPr/>
-        <p:txBody>
-          <a:bodyPr/>
-          <a:lstStyle/>
-          <a:p>
-            <a:r>
-              <a:t>Thank the group + organizers. Invite them to clone the repo and try it.</a:t>
+              <a:t>Today is intentionally focused on one thing: Foundry Toolkit for VS Code.</a:t>
+            </a:r>
+          </a:p>
+          <a:p>
+            <a:r>
+              <a:t>    No deep framework internals. Just a repeatable workflow attendees can use right away.</a:t>
             </a:r>
           </a:p>
         </p:txBody>
@@ -1195,7 +589,7 @@
           <a:lstStyle/>
           <a:p>
             <a:r>
-              <a:t>Roadmap slide. ~3 min of framing, ~10 min concepts, ~10 min demo, ~2 min wrap.</a:t>
+              <a:t>Set context quickly: this is a productivity and reliability story.</a:t>
             </a:r>
           </a:p>
         </p:txBody>
@@ -1265,17 +659,7 @@
           <a:lstStyle/>
           <a:p>
             <a:r>
-              <a:t>Framing. The hard part of 'agentic' is orchestration complexity, not model access.</a:t>
-            </a:r>
-          </a:p>
-          <a:p>
-            <a:r>
-              <a:t>If a single tool-calling loop solves it, you don't need a framework. MAF earns its keep</a:t>
-            </a:r>
-          </a:p>
-          <a:p>
-            <a:r>
-              <a:t>when coordination is the challenge.</a:t>
+              <a:t>Tell audience this is hands-on and reproducible.</a:t>
             </a:r>
           </a:p>
         </p:txBody>
@@ -1345,12 +729,7 @@
           <a:lstStyle/>
           <a:p>
             <a:r>
-              <a:t>MAF combines AutoGen + SK and adds workflows. Emphasize: not a rewrite of everything —</a:t>
-            </a:r>
-          </a:p>
-          <a:p>
-            <a:r>
-              <a:t>it's the convergence point. Mention it's a fast-moving 1.x (we pin the version in the repo).</a:t>
+              <a:t>Transition into live walkthrough.</a:t>
             </a:r>
           </a:p>
         </p:txBody>
@@ -1420,7 +799,7 @@
           <a:lstStyle/>
           <a:p>
             <a:r>
-              <a:t>This is exactly what you first build/test in the Foundry Toolkit Playground &amp; Agent Builder.</a:t>
+              <a:t>Run one clean sample during the session to keep it simple and reliable.</a:t>
             </a:r>
           </a:p>
         </p:txBody>
@@ -1490,222 +869,7 @@
           <a:lstStyle/>
           <a:p>
             <a:r>
-              <a:t>The heart of the talk. These prebuilt patterns handle the coordination boilerplate.</a:t>
-            </a:r>
-          </a:p>
-          <a:p>
-            <a:r>
-              <a:t>We'll show each with one diagram + a couple lines of code, then demo them.</a:t>
-            </a:r>
-          </a:p>
-        </p:txBody>
-      </p:sp>
-      <p:sp>
-        <p:nvSpPr>
-          <p:cNvPr id="4" name="Slide Number Placeholder 3"/>
-          <p:cNvSpPr>
-            <a:spLocks noGrp="1"/>
-          </p:cNvSpPr>
-          <p:nvPr>
-            <p:ph type="sldNum" idx="5" sz="quarter"/>
-          </p:nvPr>
-        </p:nvSpPr>
-        <p:spPr/>
-      </p:sp>
-    </p:spTree>
-  </p:cSld>
-  <p:clrMapOvr>
-    <a:masterClrMapping/>
-  </p:clrMapOvr>
-</p:notes>
-</file>
-
-<file path=ppt/notesSlides/notesSlide7.xml><?xml version="1.0" encoding="utf-8"?>
-<p:notes xmlns:a="http://schemas.openxmlformats.org/drawingml/2006/main" xmlns:p="http://schemas.openxmlformats.org/presentationml/2006/main" xmlns:r="http://schemas.openxmlformats.org/officeDocument/2006/relationships">
-  <p:cSld>
-    <p:spTree>
-      <p:nvGrpSpPr>
-        <p:cNvPr id="1" name=""/>
-        <p:cNvGrpSpPr/>
-        <p:nvPr/>
-      </p:nvGrpSpPr>
-      <p:grpSpPr>
-        <a:xfrm>
-          <a:off x="0" y="0"/>
-          <a:ext cx="0" cy="0"/>
-          <a:chOff x="0" y="0"/>
-          <a:chExt cx="0" cy="0"/>
-        </a:xfrm>
-      </p:grpSpPr>
-      <p:sp>
-        <p:nvSpPr>
-          <p:cNvPr id="2" name="Slide Image Placeholder 1"/>
-          <p:cNvSpPr>
-            <a:spLocks noGrp="1"/>
-          </p:cNvSpPr>
-          <p:nvPr>
-            <p:ph type="sldImg" idx="2"/>
-          </p:nvPr>
-        </p:nvSpPr>
-        <p:spPr/>
-      </p:sp>
-      <p:sp>
-        <p:nvSpPr>
-          <p:cNvPr id="3" name="Notes Placeholder 2"/>
-          <p:cNvSpPr>
-            <a:spLocks noGrp="1"/>
-          </p:cNvSpPr>
-          <p:nvPr>
-            <p:ph type="body" idx="3" sz="quarter"/>
-          </p:nvPr>
-        </p:nvSpPr>
-        <p:spPr/>
-        <p:txBody>
-          <a:bodyPr/>
-          <a:lstStyle/>
-          <a:p>
-            <a:r>
-              <a:t>Content pipeline. Point out how little code the pattern is.</a:t>
-            </a:r>
-          </a:p>
-        </p:txBody>
-      </p:sp>
-      <p:sp>
-        <p:nvSpPr>
-          <p:cNvPr id="4" name="Slide Number Placeholder 3"/>
-          <p:cNvSpPr>
-            <a:spLocks noGrp="1"/>
-          </p:cNvSpPr>
-          <p:nvPr>
-            <p:ph type="sldNum" idx="5" sz="quarter"/>
-          </p:nvPr>
-        </p:nvSpPr>
-        <p:spPr/>
-      </p:sp>
-    </p:spTree>
-  </p:cSld>
-  <p:clrMapOvr>
-    <a:masterClrMapping/>
-  </p:clrMapOvr>
-</p:notes>
-</file>
-
-<file path=ppt/notesSlides/notesSlide8.xml><?xml version="1.0" encoding="utf-8"?>
-<p:notes xmlns:a="http://schemas.openxmlformats.org/drawingml/2006/main" xmlns:p="http://schemas.openxmlformats.org/presentationml/2006/main" xmlns:r="http://schemas.openxmlformats.org/officeDocument/2006/relationships">
-  <p:cSld>
-    <p:spTree>
-      <p:nvGrpSpPr>
-        <p:cNvPr id="1" name=""/>
-        <p:cNvGrpSpPr/>
-        <p:nvPr/>
-      </p:nvGrpSpPr>
-      <p:grpSpPr>
-        <a:xfrm>
-          <a:off x="0" y="0"/>
-          <a:ext cx="0" cy="0"/>
-          <a:chOff x="0" y="0"/>
-          <a:chExt cx="0" cy="0"/>
-        </a:xfrm>
-      </p:grpSpPr>
-      <p:sp>
-        <p:nvSpPr>
-          <p:cNvPr id="2" name="Slide Image Placeholder 1"/>
-          <p:cNvSpPr>
-            <a:spLocks noGrp="1"/>
-          </p:cNvSpPr>
-          <p:nvPr>
-            <p:ph type="sldImg" idx="2"/>
-          </p:nvPr>
-        </p:nvSpPr>
-        <p:spPr/>
-      </p:sp>
-      <p:sp>
-        <p:nvSpPr>
-          <p:cNvPr id="3" name="Notes Placeholder 2"/>
-          <p:cNvSpPr>
-            <a:spLocks noGrp="1"/>
-          </p:cNvSpPr>
-          <p:nvPr>
-            <p:ph type="body" idx="3" sz="quarter"/>
-          </p:nvPr>
-        </p:nvSpPr>
-        <p:spPr/>
-        <p:txBody>
-          <a:bodyPr/>
-          <a:lstStyle/>
-          <a:p>
-            <a:r>
-              <a:t>Three reviewers look at the same copy at once instead of waiting in line.</a:t>
-            </a:r>
-          </a:p>
-        </p:txBody>
-      </p:sp>
-      <p:sp>
-        <p:nvSpPr>
-          <p:cNvPr id="4" name="Slide Number Placeholder 3"/>
-          <p:cNvSpPr>
-            <a:spLocks noGrp="1"/>
-          </p:cNvSpPr>
-          <p:nvPr>
-            <p:ph type="sldNum" idx="5" sz="quarter"/>
-          </p:nvPr>
-        </p:nvSpPr>
-        <p:spPr/>
-      </p:sp>
-    </p:spTree>
-  </p:cSld>
-  <p:clrMapOvr>
-    <a:masterClrMapping/>
-  </p:clrMapOvr>
-</p:notes>
-</file>
-
-<file path=ppt/notesSlides/notesSlide9.xml><?xml version="1.0" encoding="utf-8"?>
-<p:notes xmlns:a="http://schemas.openxmlformats.org/drawingml/2006/main" xmlns:p="http://schemas.openxmlformats.org/presentationml/2006/main" xmlns:r="http://schemas.openxmlformats.org/officeDocument/2006/relationships">
-  <p:cSld>
-    <p:spTree>
-      <p:nvGrpSpPr>
-        <p:cNvPr id="1" name=""/>
-        <p:cNvGrpSpPr/>
-        <p:nvPr/>
-      </p:nvGrpSpPr>
-      <p:grpSpPr>
-        <a:xfrm>
-          <a:off x="0" y="0"/>
-          <a:ext cx="0" cy="0"/>
-          <a:chOff x="0" y="0"/>
-          <a:chExt cx="0" cy="0"/>
-        </a:xfrm>
-      </p:grpSpPr>
-      <p:sp>
-        <p:nvSpPr>
-          <p:cNvPr id="2" name="Slide Image Placeholder 1"/>
-          <p:cNvSpPr>
-            <a:spLocks noGrp="1"/>
-          </p:cNvSpPr>
-          <p:nvPr>
-            <p:ph type="sldImg" idx="2"/>
-          </p:nvPr>
-        </p:nvSpPr>
-        <p:spPr/>
-      </p:sp>
-      <p:sp>
-        <p:nvSpPr>
-          <p:cNvPr id="3" name="Notes Placeholder 2"/>
-          <p:cNvSpPr>
-            <a:spLocks noGrp="1"/>
-          </p:cNvSpPr>
-          <p:nvPr>
-            <p:ph type="body" idx="3" sz="quarter"/>
-          </p:nvPr>
-        </p:nvSpPr>
-        <p:spPr/>
-        <p:txBody>
-          <a:bodyPr/>
-          <a:lstStyle/>
-          <a:p>
-            <a:r>
-              <a:t>Support desk. Triage doesn't answer — it routes. Specialists own their tools.</a:t>
+              <a:t>Explain that tracing gives transparent execution details for debugging and trust.</a:t>
             </a:r>
           </a:p>
         </p:txBody>
@@ -4763,7 +3927,7 @@
         <p:spPr>
           <a:xfrm>
             <a:off x="700000" y="2200000"/>
-            <a:ext cx="10800000" cy="2000000"/>
+            <a:ext cx="10800000" cy="2200000"/>
           </a:xfrm>
           <a:prstGeom prst="rect">
             <a:avLst/>
@@ -4782,7 +3946,7 @@
                   <a:srgbClr val="FFFFFF"/>
                 </a:solidFill>
               </a:rPr>
-              <a:t>Agent development got faster</a:t>
+              <a:t>Foundry Toolkit for VS Code</a:t>
             </a:r>
           </a:p>
           <a:p>
@@ -4792,8 +3956,8 @@
                   <a:srgbClr val="E8F0FB"/>
                 </a:solidFill>
               </a:rPr>
-              <a:t>Microsoft Agent Framework · stable orchestration building blocks
-+ Foundry Toolkit for VS Code (GA)</a:t>
+              <a:t>A simple, practical Build 2026 recap session
+focused on the in-editor AI dev loop</a:t>
             </a:r>
           </a:p>
         </p:txBody>
@@ -4826,7 +3990,7 @@
                   <a:srgbClr val="D6E6F7"/>
                 </a:solidFill>
               </a:rPr>
-              <a:t>Microsoft Build 2026 Recap — Metro Toronto Azure Community · 25-min session</a:t>
+              <a:t>Metro Toronto Azure Community · 25-minute session</a:t>
             </a:r>
           </a:p>
         </p:txBody>
@@ -4901,7 +4065,7 @@
         <p:spPr>
           <a:xfrm>
             <a:off x="600000" y="300000"/>
-            <a:ext cx="11000000" cy="800000"/>
+            <a:ext cx="11000000" cy="900000"/>
           </a:xfrm>
           <a:prstGeom prst="rect">
             <a:avLst/>
@@ -4915,166 +4079,36 @@
           <a:lstStyle/>
           <a:p>
             <a:r>
-              <a:rPr sz="2800" b="1">
+              <a:rPr sz="3000" b="1">
                 <a:solidFill>
                   <a:srgbClr val="202020"/>
                 </a:solidFill>
               </a:rPr>
-              <a:t>4 · Group Chat + 5 · Magentic</a:t>
-            </a:r>
-          </a:p>
-        </p:txBody>
-      </p:sp>
-      <p:sp>
-        <p:nvSpPr>
-          <p:cNvPr id="4" name="Rectangle 3"/>
-          <p:cNvSpPr/>
-          <p:nvPr/>
-        </p:nvSpPr>
-        <p:spPr>
-          <a:xfrm>
-            <a:off x="600000" y="1350000"/>
-            <a:ext cx="11000000" cy="4650000"/>
-          </a:xfrm>
-          <a:prstGeom prst="rect">
-            <a:avLst/>
-          </a:prstGeom>
-          <a:solidFill>
-            <a:srgbClr val="1E1E1E"/>
-          </a:solidFill>
-          <a:ln>
-            <a:noFill/>
-          </a:ln>
-        </p:spPr>
-        <p:style>
-          <a:lnRef idx="1">
-            <a:schemeClr val="accent1"/>
-          </a:lnRef>
-          <a:fillRef idx="3">
-            <a:schemeClr val="accent1"/>
-          </a:fillRef>
-          <a:effectRef idx="2">
-            <a:schemeClr val="accent1"/>
-          </a:effectRef>
-          <a:fontRef idx="minor">
-            <a:schemeClr val="lt1"/>
-          </a:fontRef>
-        </p:style>
-        <p:txBody>
-          <a:bodyPr rtlCol="0" anchor="t" wrap="square" lIns="200000" tIns="150000"/>
-          <a:lstStyle/>
-          <a:p>
-            <a:pPr algn="ctr"/>
-            <a:r>
-              <a:rPr sz="1400">
-                <a:solidFill>
-                  <a:srgbClr val="E6E6E6"/>
-                </a:solidFill>
-                <a:latin typeface="Menlo"/>
+              <a:t>6) Evaluation</a:t>
+            </a:r>
+          </a:p>
+          <a:p>
+            <a:r>
+              <a:rPr sz="1500" i="1">
+                <a:solidFill>
+                  <a:srgbClr val="606060"/>
+                </a:solidFill>
               </a:rPr>
-              <a:t># Group chat: shared conversation until convergence</a:t>
-            </a:r>
-          </a:p>
-          <a:p>
-            <a:r>
-              <a:rPr sz="1400">
-                <a:solidFill>
-                  <a:srgbClr val="E6E6E6"/>
-                </a:solidFill>
-                <a:latin typeface="Menlo"/>
-              </a:rPr>
-              <a:t>gc = GroupChatBuilder(participants=[copywriter, editor],</a:t>
-            </a:r>
-          </a:p>
-          <a:p>
-            <a:r>
-              <a:rPr sz="1400">
-                <a:solidFill>
-                  <a:srgbClr val="E6E6E6"/>
-                </a:solidFill>
-                <a:latin typeface="Menlo"/>
-              </a:rPr>
-              <a:t>                      selection_func=round_robin,</a:t>
-            </a:r>
-          </a:p>
-          <a:p>
-            <a:r>
-              <a:rPr sz="1400">
-                <a:solidFill>
-                  <a:srgbClr val="E6E6E6"/>
-                </a:solidFill>
-                <a:latin typeface="Menlo"/>
-              </a:rPr>
-              <a:t>                      termination_condition=shipped).build()</a:t>
-            </a:r>
-          </a:p>
-          <a:p>
-            <a:r>
-              <a:rPr sz="1400">
-                <a:solidFill>
-                  <a:srgbClr val="E6E6E6"/>
-                </a:solidFill>
-                <a:latin typeface="Menlo"/>
-              </a:rPr>
-              <a:t> </a:t>
-            </a:r>
-          </a:p>
-          <a:p>
-            <a:r>
-              <a:rPr sz="1400">
-                <a:solidFill>
-                  <a:srgbClr val="E6E6E6"/>
-                </a:solidFill>
-                <a:latin typeface="Menlo"/>
-              </a:rPr>
-              <a:t># Magentic: a manager plans &amp; coordinates specialists</a:t>
-            </a:r>
-          </a:p>
-          <a:p>
-            <a:r>
-              <a:rPr sz="1400">
-                <a:solidFill>
-                  <a:srgbClr val="E6E6E6"/>
-                </a:solidFill>
-                <a:latin typeface="Menlo"/>
-              </a:rPr>
-              <a:t>mg = MagenticBuilder(participants=[researcher, analyst],</a:t>
-            </a:r>
-          </a:p>
-          <a:p>
-            <a:r>
-              <a:rPr sz="1400">
-                <a:solidFill>
-                  <a:srgbClr val="E6E6E6"/>
-                </a:solidFill>
-                <a:latin typeface="Menlo"/>
-              </a:rPr>
-              <a:t>                     manager_agent=launch_manager,</a:t>
-            </a:r>
-          </a:p>
-          <a:p>
-            <a:r>
-              <a:rPr sz="1400">
-                <a:solidFill>
-                  <a:srgbClr val="E6E6E6"/>
-                </a:solidFill>
-                <a:latin typeface="Menlo"/>
-              </a:rPr>
-              <a:t>                     max_round_count=8, max_stall_count=2).build()</a:t>
-            </a:r>
-          </a:p>
-        </p:txBody>
-      </p:sp>
-      <p:sp>
-        <p:nvSpPr>
-          <p:cNvPr id="5" name="TextBox 4"/>
+              <a:t>Outcome: measurable quality, not guesswork</a:t>
+            </a:r>
+          </a:p>
+        </p:txBody>
+      </p:sp>
+      <p:sp>
+        <p:nvSpPr>
+          <p:cNvPr id="4" name="TextBox 3"/>
           <p:cNvSpPr txBox="1"/>
           <p:nvPr/>
         </p:nvSpPr>
         <p:spPr>
           <a:xfrm>
-            <a:off x="600000" y="6150000"/>
-            <a:ext cx="11000000" cy="500000"/>
+            <a:off x="700000" y="1500000"/>
+            <a:ext cx="10800000" cy="4900000"/>
           </a:xfrm>
           <a:prstGeom prst="rect">
             <a:avLst/>
@@ -5087,13 +4121,48 @@
           </a:bodyPr>
           <a:lstStyle/>
           <a:p>
-            <a:r>
-              <a:rPr sz="1300" i="1">
-                <a:solidFill>
-                  <a:srgbClr val="606060"/>
+            <a:pPr>
+              <a:spcAft>
+                <a:spcPts val="600"/>
+              </a:spcAft>
+            </a:pPr>
+            <a:r>
+              <a:rPr sz="2000">
+                <a:solidFill>
+                  <a:srgbClr val="202020"/>
                 </a:solidFill>
               </a:rPr>
-              <a:t>demos/04_group_chat.py · demos/05_magentic.py</a:t>
+              <a:t>•  Load foundry-toolkit/evaluation/dataset.jsonl</a:t>
+            </a:r>
+          </a:p>
+          <a:p>
+            <a:pPr>
+              <a:spcAft>
+                <a:spcPts val="600"/>
+              </a:spcAft>
+            </a:pPr>
+            <a:r>
+              <a:rPr sz="2000">
+                <a:solidFill>
+                  <a:srgbClr val="202020"/>
+                </a:solidFill>
+              </a:rPr>
+              <a:t>•  Run built-in evaluators and compare variants</a:t>
+            </a:r>
+          </a:p>
+          <a:p>
+            <a:pPr>
+              <a:spcAft>
+                <a:spcPts val="600"/>
+              </a:spcAft>
+            </a:pPr>
+            <a:r>
+              <a:rPr sz="2000">
+                <a:solidFill>
+                  <a:srgbClr val="202020"/>
+                </a:solidFill>
+              </a:rPr>
+              <a:t>•  Use results as quality gates before broader rollout</a:t>
             </a:r>
           </a:p>
         </p:txBody>
@@ -5168,7 +4237,7 @@
         <p:spPr>
           <a:xfrm>
             <a:off x="600000" y="300000"/>
-            <a:ext cx="11000000" cy="800000"/>
+            <a:ext cx="11000000" cy="900000"/>
           </a:xfrm>
           <a:prstGeom prst="rect">
             <a:avLst/>
@@ -5182,199 +4251,26 @@
           <a:lstStyle/>
           <a:p>
             <a:r>
-              <a:rPr sz="2800" b="1">
+              <a:rPr sz="3000" b="1">
                 <a:solidFill>
                   <a:srgbClr val="202020"/>
                 </a:solidFill>
               </a:rPr>
-              <a:t>Human-in-the-loop = one flag</a:t>
-            </a:r>
-          </a:p>
-        </p:txBody>
-      </p:sp>
-      <p:sp>
-        <p:nvSpPr>
-          <p:cNvPr id="4" name="Rectangle 3"/>
-          <p:cNvSpPr/>
-          <p:nvPr/>
-        </p:nvSpPr>
-        <p:spPr>
-          <a:xfrm>
-            <a:off x="600000" y="1350000"/>
-            <a:ext cx="11000000" cy="4650000"/>
-          </a:xfrm>
-          <a:prstGeom prst="rect">
-            <a:avLst/>
-          </a:prstGeom>
-          <a:solidFill>
-            <a:srgbClr val="1E1E1E"/>
-          </a:solidFill>
-          <a:ln>
-            <a:noFill/>
-          </a:ln>
-        </p:spPr>
-        <p:style>
-          <a:lnRef idx="1">
-            <a:schemeClr val="accent1"/>
-          </a:lnRef>
-          <a:fillRef idx="3">
-            <a:schemeClr val="accent1"/>
-          </a:fillRef>
-          <a:effectRef idx="2">
-            <a:schemeClr val="accent1"/>
-          </a:effectRef>
-          <a:fontRef idx="minor">
-            <a:schemeClr val="lt1"/>
-          </a:fontRef>
-        </p:style>
-        <p:txBody>
-          <a:bodyPr rtlCol="0" anchor="t" wrap="square" lIns="200000" tIns="150000"/>
-          <a:lstStyle/>
-          <a:p>
-            <a:pPr algn="ctr"/>
-            <a:r>
-              <a:rPr sz="1400">
-                <a:solidFill>
-                  <a:srgbClr val="E6E6E6"/>
-                </a:solidFill>
-                <a:latin typeface="Menlo"/>
-              </a:rPr>
-              <a:t>from agent_framework import tool</a:t>
-            </a:r>
-          </a:p>
-          <a:p>
-            <a:r>
-              <a:rPr sz="1400">
-                <a:solidFill>
-                  <a:srgbClr val="E6E6E6"/>
-                </a:solidFill>
-                <a:latin typeface="Menlo"/>
-              </a:rPr>
-              <a:t> </a:t>
-            </a:r>
-          </a:p>
-          <a:p>
-            <a:r>
-              <a:rPr sz="1400">
-                <a:solidFill>
-                  <a:srgbClr val="E6E6E6"/>
-                </a:solidFill>
-                <a:latin typeface="Menlo"/>
-              </a:rPr>
-              <a:t>@tool(approval_mode="always_require")</a:t>
-            </a:r>
-          </a:p>
-          <a:p>
-            <a:r>
-              <a:rPr sz="1400">
-                <a:solidFill>
-                  <a:srgbClr val="E6E6E6"/>
-                </a:solidFill>
-                <a:latin typeface="Menlo"/>
-              </a:rPr>
-              <a:t>def publish_blog(title: str, body: str) -&gt; str:</a:t>
-            </a:r>
-          </a:p>
-          <a:p>
-            <a:r>
-              <a:rPr sz="1400">
-                <a:solidFill>
-                  <a:srgbClr val="E6E6E6"/>
-                </a:solidFill>
-                <a:latin typeface="Menlo"/>
-              </a:rPr>
-              <a:t>    return f"PUBLISHED: {title}"</a:t>
-            </a:r>
-          </a:p>
-          <a:p>
-            <a:r>
-              <a:rPr sz="1400">
-                <a:solidFill>
-                  <a:srgbClr val="E6E6E6"/>
-                </a:solidFill>
-                <a:latin typeface="Menlo"/>
-              </a:rPr>
-              <a:t> </a:t>
-            </a:r>
-          </a:p>
-          <a:p>
-            <a:r>
-              <a:rPr sz="1400">
-                <a:solidFill>
-                  <a:srgbClr val="E6E6E6"/>
-                </a:solidFill>
-                <a:latin typeface="Menlo"/>
-              </a:rPr>
-              <a:t># The run pauses and surfaces an approval request:</a:t>
-            </a:r>
-          </a:p>
-          <a:p>
-            <a:r>
-              <a:rPr sz="1400">
-                <a:solidFill>
-                  <a:srgbClr val="E6E6E6"/>
-                </a:solidFill>
-                <a:latin typeface="Menlo"/>
-              </a:rPr>
-              <a:t>result = await workflow.run(task)</a:t>
-            </a:r>
-          </a:p>
-          <a:p>
-            <a:r>
-              <a:rPr sz="1400">
-                <a:solidFill>
-                  <a:srgbClr val="E6E6E6"/>
-                </a:solidFill>
-                <a:latin typeface="Menlo"/>
-              </a:rPr>
-              <a:t>for ev in result.get_request_info_events():</a:t>
-            </a:r>
-          </a:p>
-          <a:p>
-            <a:r>
-              <a:rPr sz="1400">
-                <a:solidFill>
-                  <a:srgbClr val="E6E6E6"/>
-                </a:solidFill>
-                <a:latin typeface="Menlo"/>
-              </a:rPr>
-              <a:t>    req = ev.data                       # function_approval_request</a:t>
-            </a:r>
-          </a:p>
-          <a:p>
-            <a:r>
-              <a:rPr sz="1400">
-                <a:solidFill>
-                  <a:srgbClr val="E6E6E6"/>
-                </a:solidFill>
-                <a:latin typeface="Menlo"/>
-              </a:rPr>
-              <a:t>    responses[ev.request_id] = req.to_function_approval_response(approved=True)</a:t>
-            </a:r>
-          </a:p>
-          <a:p>
-            <a:r>
-              <a:rPr sz="1400">
-                <a:solidFill>
-                  <a:srgbClr val="E6E6E6"/>
-                </a:solidFill>
-                <a:latin typeface="Menlo"/>
-              </a:rPr>
-              <a:t>result = await workflow.run(responses=responses)</a:t>
-            </a:r>
-          </a:p>
-        </p:txBody>
-      </p:sp>
-      <p:sp>
-        <p:nvSpPr>
-          <p:cNvPr id="5" name="TextBox 4"/>
+              <a:t>Demo checklist you can reuse</a:t>
+            </a:r>
+          </a:p>
+        </p:txBody>
+      </p:sp>
+      <p:sp>
+        <p:nvSpPr>
+          <p:cNvPr id="4" name="TextBox 3"/>
           <p:cNvSpPr txBox="1"/>
           <p:nvPr/>
         </p:nvSpPr>
         <p:spPr>
           <a:xfrm>
-            <a:off x="600000" y="6150000"/>
-            <a:ext cx="11000000" cy="500000"/>
+            <a:off x="700000" y="1500000"/>
+            <a:ext cx="10800000" cy="4900000"/>
           </a:xfrm>
           <a:prstGeom prst="rect">
             <a:avLst/>
@@ -5387,13 +4283,63 @@
           </a:bodyPr>
           <a:lstStyle/>
           <a:p>
-            <a:r>
-              <a:rPr sz="1300" i="1">
-                <a:solidFill>
-                  <a:srgbClr val="606060"/>
+            <a:pPr>
+              <a:spcAft>
+                <a:spcPts val="600"/>
+              </a:spcAft>
+            </a:pPr>
+            <a:r>
+              <a:rPr sz="2000">
+                <a:solidFill>
+                  <a:srgbClr val="202020"/>
                 </a:solidFill>
               </a:rPr>
-              <a:t>demos/06_hitl_approval.py — write tools auto-run, high-impact tools ask first</a:t>
+              <a:t>•  Preflight: smoke test + single-agent run</a:t>
+            </a:r>
+          </a:p>
+          <a:p>
+            <a:pPr>
+              <a:spcAft>
+                <a:spcPts val="600"/>
+              </a:spcAft>
+            </a:pPr>
+            <a:r>
+              <a:rPr sz="2000">
+                <a:solidFill>
+                  <a:srgbClr val="202020"/>
+                </a:solidFill>
+              </a:rPr>
+              <a:t>•  Keep one golden prompt and one fallback backend</a:t>
+            </a:r>
+          </a:p>
+          <a:p>
+            <a:pPr>
+              <a:spcAft>
+                <a:spcPts val="600"/>
+              </a:spcAft>
+            </a:pPr>
+            <a:r>
+              <a:rPr sz="2000">
+                <a:solidFill>
+                  <a:srgbClr val="202020"/>
+                </a:solidFill>
+              </a:rPr>
+              <a:t>•  Prefer one successful end-to-end loop over many partial demos</a:t>
+            </a:r>
+          </a:p>
+          <a:p>
+            <a:pPr>
+              <a:spcAft>
+                <a:spcPts val="600"/>
+              </a:spcAft>
+            </a:pPr>
+            <a:r>
+              <a:rPr sz="2000">
+                <a:solidFill>
+                  <a:srgbClr val="202020"/>
+                </a:solidFill>
+              </a:rPr>
+              <a:t>•  If issues occur, pivot to Inspector/Tracing screenshots and continue</a:t>
             </a:r>
           </a:p>
         </p:txBody>
@@ -5425,13 +4371,13 @@
         <p:spPr>
           <a:xfrm>
             <a:off x="0" y="0"/>
-            <a:ext cx="12192000" cy="6858000"/>
+            <a:ext cx="12192000" cy="120000"/>
           </a:xfrm>
           <a:prstGeom prst="rect">
             <a:avLst/>
           </a:prstGeom>
           <a:solidFill>
-            <a:srgbClr val="202020"/>
+            <a:srgbClr val="0078D4"/>
           </a:solidFill>
           <a:ln>
             <a:noFill/>
@@ -5467,8 +4413,8 @@
         </p:nvSpPr>
         <p:spPr>
           <a:xfrm>
-            <a:off x="700000" y="2700000"/>
-            <a:ext cx="10800000" cy="1600000"/>
+            <a:off x="600000" y="300000"/>
+            <a:ext cx="11000000" cy="900000"/>
           </a:xfrm>
           <a:prstGeom prst="rect">
             <a:avLst/>
@@ -5482,22 +4428,110 @@
           <a:lstStyle/>
           <a:p>
             <a:r>
-              <a:rPr sz="1600" b="1">
-                <a:solidFill>
-                  <a:srgbClr val="0078D4"/>
+              <a:rPr sz="3000" b="1">
+                <a:solidFill>
+                  <a:srgbClr val="202020"/>
                 </a:solidFill>
               </a:rPr>
-              <a:t>NOW: HOW DO YOU BUILD ALL THIS?</a:t>
-            </a:r>
-          </a:p>
-          <a:p>
-            <a:r>
-              <a:rPr sz="4000" b="1">
-                <a:solidFill>
-                  <a:srgbClr val="FFFFFF"/>
+              <a:t>Resources</a:t>
+            </a:r>
+          </a:p>
+        </p:txBody>
+      </p:sp>
+      <p:sp>
+        <p:nvSpPr>
+          <p:cNvPr id="4" name="TextBox 3"/>
+          <p:cNvSpPr txBox="1"/>
+          <p:nvPr/>
+        </p:nvSpPr>
+        <p:spPr>
+          <a:xfrm>
+            <a:off x="700000" y="1500000"/>
+            <a:ext cx="10800000" cy="4900000"/>
+          </a:xfrm>
+          <a:prstGeom prst="rect">
+            <a:avLst/>
+          </a:prstGeom>
+          <a:noFill/>
+        </p:spPr>
+        <p:txBody>
+          <a:bodyPr wrap="square">
+            <a:spAutoFit/>
+          </a:bodyPr>
+          <a:lstStyle/>
+          <a:p>
+            <a:pPr>
+              <a:spcAft>
+                <a:spcPts val="600"/>
+              </a:spcAft>
+            </a:pPr>
+            <a:r>
+              <a:rPr sz="2000">
+                <a:solidFill>
+                  <a:srgbClr val="202020"/>
                 </a:solidFill>
               </a:rPr>
-              <a:t>Foundry Toolkit for VS Code — now GA</a:t>
+              <a:t>•  Foundry Toolkit overview: code.visualstudio.com/docs/intelligentapps/overview</a:t>
+            </a:r>
+          </a:p>
+          <a:p>
+            <a:pPr>
+              <a:spcAft>
+                <a:spcPts val="600"/>
+              </a:spcAft>
+            </a:pPr>
+            <a:r>
+              <a:rPr sz="2000">
+                <a:solidFill>
+                  <a:srgbClr val="202020"/>
+                </a:solidFill>
+              </a:rPr>
+              <a:t>•  Install link: aka.ms/foundrytk</a:t>
+            </a:r>
+          </a:p>
+          <a:p>
+            <a:pPr>
+              <a:spcAft>
+                <a:spcPts val="600"/>
+              </a:spcAft>
+            </a:pPr>
+            <a:r>
+              <a:rPr sz="2000">
+                <a:solidFill>
+                  <a:srgbClr val="202020"/>
+                </a:solidFill>
+              </a:rPr>
+              <a:t>•  Session runbook: docs/DEMO_SCRIPT.md</a:t>
+            </a:r>
+          </a:p>
+          <a:p>
+            <a:pPr>
+              <a:spcAft>
+                <a:spcPts val="600"/>
+              </a:spcAft>
+            </a:pPr>
+            <a:r>
+              <a:rPr sz="2000">
+                <a:solidFill>
+                  <a:srgbClr val="202020"/>
+                </a:solidFill>
+              </a:rPr>
+              <a:t>•  Toolkit demo guide: foundry-toolkit/README.md</a:t>
+            </a:r>
+          </a:p>
+          <a:p>
+            <a:pPr>
+              <a:spcAft>
+                <a:spcPts val="600"/>
+              </a:spcAft>
+            </a:pPr>
+            <a:r>
+              <a:rPr sz="2000">
+                <a:solidFill>
+                  <a:srgbClr val="202020"/>
+                </a:solidFill>
+              </a:rPr>
+              <a:t>•  Repo: github.com/hkaanturgut/agent-framework-foundry-demo</a:t>
             </a:r>
           </a:p>
         </p:txBody>
@@ -5529,7 +4563,7 @@
         <p:spPr>
           <a:xfrm>
             <a:off x="0" y="0"/>
-            <a:ext cx="12192000" cy="120000"/>
+            <a:ext cx="12192000" cy="6858000"/>
           </a:xfrm>
           <a:prstGeom prst="rect">
             <a:avLst/>
@@ -5571,8 +4605,8 @@
         </p:nvSpPr>
         <p:spPr>
           <a:xfrm>
-            <a:off x="600000" y="300000"/>
-            <a:ext cx="11000000" cy="900000"/>
+            <a:off x="700000" y="2200000"/>
+            <a:ext cx="10800000" cy="2200000"/>
           </a:xfrm>
           <a:prstGeom prst="rect">
             <a:avLst/>
@@ -5586,22 +4620,23 @@
           <a:lstStyle/>
           <a:p>
             <a:r>
-              <a:rPr sz="3000" b="1">
-                <a:solidFill>
-                  <a:srgbClr val="202020"/>
+              <a:rPr sz="4400" b="1">
+                <a:solidFill>
+                  <a:srgbClr val="FFFFFF"/>
                 </a:solidFill>
               </a:rPr>
-              <a:t>Foundry Toolkit for VS Code (GA)</a:t>
-            </a:r>
-          </a:p>
-          <a:p>
-            <a:r>
-              <a:rPr sz="1500" i="1">
-                <a:solidFill>
-                  <a:srgbClr val="606060"/>
+              <a:t>Thank you!</a:t>
+            </a:r>
+          </a:p>
+          <a:p>
+            <a:r>
+              <a:rPr sz="2200">
+                <a:solidFill>
+                  <a:srgbClr val="E8F0FB"/>
                 </a:solidFill>
               </a:rPr>
-              <a:t>Formerly 'AI Toolkit for VS Code' · install: aka.ms/foundrytk</a:t>
+              <a:t>Questions?
+If you only remember one thing: run the full loop inside VS Code.</a:t>
             </a:r>
           </a:p>
         </p:txBody>
@@ -5614,8 +4649,8 @@
         </p:nvSpPr>
         <p:spPr>
           <a:xfrm>
-            <a:off x="700000" y="1500000"/>
-            <a:ext cx="10800000" cy="4900000"/>
+            <a:off x="700000" y="5900000"/>
+            <a:ext cx="10800000" cy="500000"/>
           </a:xfrm>
           <a:prstGeom prst="rect">
             <a:avLst/>
@@ -5628,1228 +4663,13 @@
           </a:bodyPr>
           <a:lstStyle/>
           <a:p>
-            <a:pPr>
-              <a:spcAft>
-                <a:spcPts val="600"/>
-              </a:spcAft>
-            </a:pPr>
-            <a:r>
-              <a:rPr sz="2000">
-                <a:solidFill>
-                  <a:srgbClr val="202020"/>
+            <a:r>
+              <a:rPr sz="1400">
+                <a:solidFill>
+                  <a:srgbClr val="D6E6F7"/>
                 </a:solidFill>
               </a:rPr>
-              <a:t>•  The full local AI dev loop — without leaving the editor</a:t>
-            </a:r>
-          </a:p>
-          <a:p>
-            <a:pPr>
-              <a:spcAft>
-                <a:spcPts val="600"/>
-              </a:spcAft>
-            </a:pPr>
-            <a:r>
-              <a:rPr sz="2000">
-                <a:solidFill>
-                  <a:srgbClr val="202020"/>
-                </a:solidFill>
-              </a:rPr>
-              <a:t>•  Model Catalog — OpenAI, Anthropic, Google, GitHub, Foundry, ONNX, Ollama</a:t>
-            </a:r>
-          </a:p>
-          <a:p>
-            <a:pPr>
-              <a:spcAft>
-                <a:spcPts val="600"/>
-              </a:spcAft>
-            </a:pPr>
-            <a:r>
-              <a:rPr sz="2000">
-                <a:solidFill>
-                  <a:srgbClr val="202020"/>
-                </a:solidFill>
-              </a:rPr>
-              <a:t>•  Playground — chat + params + multimodal, test before you code</a:t>
-            </a:r>
-          </a:p>
-          <a:p>
-            <a:pPr>
-              <a:spcAft>
-                <a:spcPts val="600"/>
-              </a:spcAft>
-            </a:pPr>
-            <a:r>
-              <a:rPr sz="2000">
-                <a:solidFill>
-                  <a:srgbClr val="202020"/>
-                </a:solidFill>
-              </a:rPr>
-              <a:t>•  Agent Builder — prompt → production code + MCP tools</a:t>
-            </a:r>
-          </a:p>
-          <a:p>
-            <a:pPr>
-              <a:spcAft>
-                <a:spcPts val="600"/>
-              </a:spcAft>
-            </a:pPr>
-            <a:r>
-              <a:rPr sz="2000">
-                <a:solidFill>
-                  <a:srgbClr val="202020"/>
-                </a:solidFill>
-              </a:rPr>
-              <a:t>•  Agent Inspector — debug &amp; visualize agents, set breakpoints</a:t>
-            </a:r>
-          </a:p>
-          <a:p>
-            <a:pPr>
-              <a:spcAft>
-                <a:spcPts val="600"/>
-              </a:spcAft>
-            </a:pPr>
-            <a:r>
-              <a:rPr sz="2000">
-                <a:solidFill>
-                  <a:srgbClr val="202020"/>
-                </a:solidFill>
-              </a:rPr>
-              <a:t>•  Evaluation — F1, relevance, coherence, similarity, custom</a:t>
-            </a:r>
-          </a:p>
-          <a:p>
-            <a:pPr>
-              <a:spcAft>
-                <a:spcPts val="600"/>
-              </a:spcAft>
-            </a:pPr>
-            <a:r>
-              <a:rPr sz="2000">
-                <a:solidFill>
-                  <a:srgbClr val="202020"/>
-                </a:solidFill>
-              </a:rPr>
-              <a:t>•  Tracing — local OTLP collector; see every step live</a:t>
-            </a:r>
-          </a:p>
-        </p:txBody>
-      </p:sp>
-    </p:spTree>
-  </p:cSld>
-  <p:clrMapOvr>
-    <a:masterClrMapping/>
-  </p:clrMapOvr>
-</p:sld>
-</file>
-
-<file path=ppt/slides/slide14.xml><?xml version="1.0" encoding="utf-8"?>
-<p:sld xmlns:a="http://schemas.openxmlformats.org/drawingml/2006/main" xmlns:p="http://schemas.openxmlformats.org/presentationml/2006/main" xmlns:r="http://schemas.openxmlformats.org/officeDocument/2006/relationships">
-  <p:cSld>
-    <p:spTree>
-      <p:nvGrpSpPr>
-        <p:cNvPr id="1" name=""/>
-        <p:cNvGrpSpPr/>
-        <p:nvPr/>
-      </p:nvGrpSpPr>
-      <p:grpSpPr/>
-      <p:sp>
-        <p:nvSpPr>
-          <p:cNvPr id="2" name="Rectangle 1"/>
-          <p:cNvSpPr/>
-          <p:nvPr/>
-        </p:nvSpPr>
-        <p:spPr>
-          <a:xfrm>
-            <a:off x="0" y="0"/>
-            <a:ext cx="12192000" cy="120000"/>
-          </a:xfrm>
-          <a:prstGeom prst="rect">
-            <a:avLst/>
-          </a:prstGeom>
-          <a:solidFill>
-            <a:srgbClr val="0078D4"/>
-          </a:solidFill>
-          <a:ln>
-            <a:noFill/>
-          </a:ln>
-        </p:spPr>
-        <p:style>
-          <a:lnRef idx="1">
-            <a:schemeClr val="accent1"/>
-          </a:lnRef>
-          <a:fillRef idx="3">
-            <a:schemeClr val="accent1"/>
-          </a:fillRef>
-          <a:effectRef idx="2">
-            <a:schemeClr val="accent1"/>
-          </a:effectRef>
-          <a:fontRef idx="minor">
-            <a:schemeClr val="lt1"/>
-          </a:fontRef>
-        </p:style>
-        <p:txBody>
-          <a:bodyPr rtlCol="0" anchor="ctr"/>
-          <a:lstStyle/>
-          <a:p>
-            <a:pPr algn="ctr"/>
-          </a:p>
-        </p:txBody>
-      </p:sp>
-      <p:sp>
-        <p:nvSpPr>
-          <p:cNvPr id="3" name="TextBox 2"/>
-          <p:cNvSpPr txBox="1"/>
-          <p:nvPr/>
-        </p:nvSpPr>
-        <p:spPr>
-          <a:xfrm>
-            <a:off x="600000" y="300000"/>
-            <a:ext cx="11000000" cy="900000"/>
-          </a:xfrm>
-          <a:prstGeom prst="rect">
-            <a:avLst/>
-          </a:prstGeom>
-          <a:noFill/>
-        </p:spPr>
-        <p:txBody>
-          <a:bodyPr wrap="square">
-            <a:spAutoFit/>
-          </a:bodyPr>
-          <a:lstStyle/>
-          <a:p>
-            <a:r>
-              <a:rPr sz="3000" b="1">
-                <a:solidFill>
-                  <a:srgbClr val="202020"/>
-                </a:solidFill>
-              </a:rPr>
-              <a:t>The inner loop these two enable</a:t>
-            </a:r>
-          </a:p>
-          <a:p>
-            <a:r>
-              <a:rPr sz="1500" i="1">
-                <a:solidFill>
-                  <a:srgbClr val="606060"/>
-                </a:solidFill>
-              </a:rPr>
-              <a:t>Faster because the loop lives in one place — editor to production</a:t>
-            </a:r>
-          </a:p>
-        </p:txBody>
-      </p:sp>
-      <p:sp>
-        <p:nvSpPr>
-          <p:cNvPr id="4" name="TextBox 3"/>
-          <p:cNvSpPr txBox="1"/>
-          <p:nvPr/>
-        </p:nvSpPr>
-        <p:spPr>
-          <a:xfrm>
-            <a:off x="700000" y="1500000"/>
-            <a:ext cx="10800000" cy="4900000"/>
-          </a:xfrm>
-          <a:prstGeom prst="rect">
-            <a:avLst/>
-          </a:prstGeom>
-          <a:noFill/>
-        </p:spPr>
-        <p:txBody>
-          <a:bodyPr wrap="square">
-            <a:spAutoFit/>
-          </a:bodyPr>
-          <a:lstStyle/>
-          <a:p>
-            <a:pPr>
-              <a:spcAft>
-                <a:spcPts val="600"/>
-              </a:spcAft>
-            </a:pPr>
-            <a:r>
-              <a:rPr sz="2000">
-                <a:solidFill>
-                  <a:srgbClr val="202020"/>
-                </a:solidFill>
-              </a:rPr>
-              <a:t>•  1. Discover a model in the Model Catalog</a:t>
-            </a:r>
-          </a:p>
-          <a:p>
-            <a:pPr>
-              <a:spcAft>
-                <a:spcPts val="600"/>
-              </a:spcAft>
-            </a:pPr>
-            <a:r>
-              <a:rPr sz="2000">
-                <a:solidFill>
-                  <a:srgbClr val="202020"/>
-                </a:solidFill>
-              </a:rPr>
-              <a:t>•  2. Test the prompt in the Playground</a:t>
-            </a:r>
-          </a:p>
-          <a:p>
-            <a:pPr>
-              <a:spcAft>
-                <a:spcPts val="600"/>
-              </a:spcAft>
-            </a:pPr>
-            <a:r>
-              <a:rPr sz="2000">
-                <a:solidFill>
-                  <a:srgbClr val="202020"/>
-                </a:solidFill>
-              </a:rPr>
-              <a:t>•  3. Build the agent in Agent Builder → generates code</a:t>
-            </a:r>
-          </a:p>
-          <a:p>
-            <a:pPr>
-              <a:spcAft>
-                <a:spcPts val="600"/>
-              </a:spcAft>
-            </a:pPr>
-            <a:r>
-              <a:rPr sz="2000">
-                <a:solidFill>
-                  <a:srgbClr val="202020"/>
-                </a:solidFill>
-              </a:rPr>
-              <a:t>•  4. Compose agents with MAF orchestration building blocks</a:t>
-            </a:r>
-          </a:p>
-          <a:p>
-            <a:pPr>
-              <a:spcAft>
-                <a:spcPts val="600"/>
-              </a:spcAft>
-            </a:pPr>
-            <a:r>
-              <a:rPr sz="2000">
-                <a:solidFill>
-                  <a:srgbClr val="202020"/>
-                </a:solidFill>
-              </a:rPr>
-              <a:t>•  5. Debug &amp; visualize in Agent Inspector</a:t>
-            </a:r>
-          </a:p>
-          <a:p>
-            <a:pPr>
-              <a:spcAft>
-                <a:spcPts val="600"/>
-              </a:spcAft>
-            </a:pPr>
-            <a:r>
-              <a:rPr sz="2000">
-                <a:solidFill>
-                  <a:srgbClr val="202020"/>
-                </a:solidFill>
-              </a:rPr>
-              <a:t>•  6. Trace locally (OTLP) + Evaluate quality</a:t>
-            </a:r>
-          </a:p>
-          <a:p>
-            <a:pPr>
-              <a:spcAft>
-                <a:spcPts val="600"/>
-              </a:spcAft>
-            </a:pPr>
-            <a:r>
-              <a:rPr sz="2000">
-                <a:solidFill>
-                  <a:srgbClr val="202020"/>
-                </a:solidFill>
-              </a:rPr>
-              <a:t>•  7. Deploy hosted agents / workflows to Foundry</a:t>
-            </a:r>
-          </a:p>
-        </p:txBody>
-      </p:sp>
-    </p:spTree>
-  </p:cSld>
-  <p:clrMapOvr>
-    <a:masterClrMapping/>
-  </p:clrMapOvr>
-</p:sld>
-</file>
-
-<file path=ppt/slides/slide15.xml><?xml version="1.0" encoding="utf-8"?>
-<p:sld xmlns:a="http://schemas.openxmlformats.org/drawingml/2006/main" xmlns:p="http://schemas.openxmlformats.org/presentationml/2006/main" xmlns:r="http://schemas.openxmlformats.org/officeDocument/2006/relationships">
-  <p:cSld>
-    <p:spTree>
-      <p:nvGrpSpPr>
-        <p:cNvPr id="1" name=""/>
-        <p:cNvGrpSpPr/>
-        <p:nvPr/>
-      </p:nvGrpSpPr>
-      <p:grpSpPr/>
-      <p:sp>
-        <p:nvSpPr>
-          <p:cNvPr id="2" name="Rectangle 1"/>
-          <p:cNvSpPr/>
-          <p:nvPr/>
-        </p:nvSpPr>
-        <p:spPr>
-          <a:xfrm>
-            <a:off x="0" y="0"/>
-            <a:ext cx="12192000" cy="6858000"/>
-          </a:xfrm>
-          <a:prstGeom prst="rect">
-            <a:avLst/>
-          </a:prstGeom>
-          <a:solidFill>
-            <a:srgbClr val="202020"/>
-          </a:solidFill>
-          <a:ln>
-            <a:noFill/>
-          </a:ln>
-        </p:spPr>
-        <p:style>
-          <a:lnRef idx="1">
-            <a:schemeClr val="accent1"/>
-          </a:lnRef>
-          <a:fillRef idx="3">
-            <a:schemeClr val="accent1"/>
-          </a:fillRef>
-          <a:effectRef idx="2">
-            <a:schemeClr val="accent1"/>
-          </a:effectRef>
-          <a:fontRef idx="minor">
-            <a:schemeClr val="lt1"/>
-          </a:fontRef>
-        </p:style>
-        <p:txBody>
-          <a:bodyPr rtlCol="0" anchor="ctr"/>
-          <a:lstStyle/>
-          <a:p>
-            <a:pPr algn="ctr"/>
-          </a:p>
-        </p:txBody>
-      </p:sp>
-      <p:sp>
-        <p:nvSpPr>
-          <p:cNvPr id="3" name="TextBox 2"/>
-          <p:cNvSpPr txBox="1"/>
-          <p:nvPr/>
-        </p:nvSpPr>
-        <p:spPr>
-          <a:xfrm>
-            <a:off x="700000" y="2700000"/>
-            <a:ext cx="10800000" cy="1600000"/>
-          </a:xfrm>
-          <a:prstGeom prst="rect">
-            <a:avLst/>
-          </a:prstGeom>
-          <a:noFill/>
-        </p:spPr>
-        <p:txBody>
-          <a:bodyPr wrap="square">
-            <a:spAutoFit/>
-          </a:bodyPr>
-          <a:lstStyle/>
-          <a:p>
-            <a:r>
-              <a:rPr sz="1600" b="1">
-                <a:solidFill>
-                  <a:srgbClr val="0078D4"/>
-                </a:solidFill>
-              </a:rPr>
-              <a:t>LIVE DEMO</a:t>
-            </a:r>
-          </a:p>
-          <a:p>
-            <a:r>
-              <a:rPr sz="4000" b="1">
-                <a:solidFill>
-                  <a:srgbClr val="FFFFFF"/>
-                </a:solidFill>
-              </a:rPr>
-              <a:t>Contoso Outdoors 'Launch Desk'</a:t>
-            </a:r>
-          </a:p>
-        </p:txBody>
-      </p:sp>
-    </p:spTree>
-  </p:cSld>
-  <p:clrMapOvr>
-    <a:masterClrMapping/>
-  </p:clrMapOvr>
-</p:sld>
-</file>
-
-<file path=ppt/slides/slide16.xml><?xml version="1.0" encoding="utf-8"?>
-<p:sld xmlns:a="http://schemas.openxmlformats.org/drawingml/2006/main" xmlns:p="http://schemas.openxmlformats.org/presentationml/2006/main" xmlns:r="http://schemas.openxmlformats.org/officeDocument/2006/relationships">
-  <p:cSld>
-    <p:spTree>
-      <p:nvGrpSpPr>
-        <p:cNvPr id="1" name=""/>
-        <p:cNvGrpSpPr/>
-        <p:nvPr/>
-      </p:nvGrpSpPr>
-      <p:grpSpPr/>
-      <p:sp>
-        <p:nvSpPr>
-          <p:cNvPr id="2" name="Rectangle 1"/>
-          <p:cNvSpPr/>
-          <p:nvPr/>
-        </p:nvSpPr>
-        <p:spPr>
-          <a:xfrm>
-            <a:off x="0" y="0"/>
-            <a:ext cx="12192000" cy="120000"/>
-          </a:xfrm>
-          <a:prstGeom prst="rect">
-            <a:avLst/>
-          </a:prstGeom>
-          <a:solidFill>
-            <a:srgbClr val="0078D4"/>
-          </a:solidFill>
-          <a:ln>
-            <a:noFill/>
-          </a:ln>
-        </p:spPr>
-        <p:style>
-          <a:lnRef idx="1">
-            <a:schemeClr val="accent1"/>
-          </a:lnRef>
-          <a:fillRef idx="3">
-            <a:schemeClr val="accent1"/>
-          </a:fillRef>
-          <a:effectRef idx="2">
-            <a:schemeClr val="accent1"/>
-          </a:effectRef>
-          <a:fontRef idx="minor">
-            <a:schemeClr val="lt1"/>
-          </a:fontRef>
-        </p:style>
-        <p:txBody>
-          <a:bodyPr rtlCol="0" anchor="ctr"/>
-          <a:lstStyle/>
-          <a:p>
-            <a:pPr algn="ctr"/>
-          </a:p>
-        </p:txBody>
-      </p:sp>
-      <p:sp>
-        <p:nvSpPr>
-          <p:cNvPr id="3" name="TextBox 2"/>
-          <p:cNvSpPr txBox="1"/>
-          <p:nvPr/>
-        </p:nvSpPr>
-        <p:spPr>
-          <a:xfrm>
-            <a:off x="600000" y="300000"/>
-            <a:ext cx="11000000" cy="900000"/>
-          </a:xfrm>
-          <a:prstGeom prst="rect">
-            <a:avLst/>
-          </a:prstGeom>
-          <a:noFill/>
-        </p:spPr>
-        <p:txBody>
-          <a:bodyPr wrap="square">
-            <a:spAutoFit/>
-          </a:bodyPr>
-          <a:lstStyle/>
-          <a:p>
-            <a:r>
-              <a:rPr sz="3000" b="1">
-                <a:solidFill>
-                  <a:srgbClr val="202020"/>
-                </a:solidFill>
-              </a:rPr>
-              <a:t>What you'll see in the demo</a:t>
-            </a:r>
-          </a:p>
-          <a:p>
-            <a:r>
-              <a:rPr sz="1500" i="1">
-                <a:solidFill>
-                  <a:srgbClr val="606060"/>
-                </a:solidFill>
-              </a:rPr>
-              <a:t>Repo: agent-framework-foundry-demo · runs on Azure OpenAI (swap backends via .env)</a:t>
-            </a:r>
-          </a:p>
-        </p:txBody>
-      </p:sp>
-      <p:sp>
-        <p:nvSpPr>
-          <p:cNvPr id="4" name="TextBox 3"/>
-          <p:cNvSpPr txBox="1"/>
-          <p:nvPr/>
-        </p:nvSpPr>
-        <p:spPr>
-          <a:xfrm>
-            <a:off x="700000" y="1500000"/>
-            <a:ext cx="10800000" cy="4900000"/>
-          </a:xfrm>
-          <a:prstGeom prst="rect">
-            <a:avLst/>
-          </a:prstGeom>
-          <a:noFill/>
-        </p:spPr>
-        <p:txBody>
-          <a:bodyPr wrap="square">
-            <a:spAutoFit/>
-          </a:bodyPr>
-          <a:lstStyle/>
-          <a:p>
-            <a:pPr>
-              <a:spcAft>
-                <a:spcPts val="600"/>
-              </a:spcAft>
-            </a:pPr>
-            <a:r>
-              <a:rPr sz="2000">
-                <a:solidFill>
-                  <a:srgbClr val="202020"/>
-                </a:solidFill>
-              </a:rPr>
-              <a:t>•  One company, five orchestration patterns, all in VS Code:</a:t>
-            </a:r>
-          </a:p>
-          <a:p>
-            <a:pPr lvl="1">
-              <a:spcAft>
-                <a:spcPts val="600"/>
-              </a:spcAft>
-            </a:pPr>
-            <a:r>
-              <a:rPr sz="1800">
-                <a:solidFill>
-                  <a:srgbClr val="606060"/>
-                </a:solidFill>
-              </a:rPr>
-              <a:t>–  Sequential — blog pipeline (Outliner ▶ Writer ▶ Editor)</a:t>
-            </a:r>
-          </a:p>
-          <a:p>
-            <a:pPr lvl="1">
-              <a:spcAft>
-                <a:spcPts val="600"/>
-              </a:spcAft>
-            </a:pPr>
-            <a:r>
-              <a:rPr sz="1800">
-                <a:solidFill>
-                  <a:srgbClr val="606060"/>
-                </a:solidFill>
-              </a:rPr>
-              <a:t>–  Concurrent — parallel review (SEO ∥ Legal ∥ Brand)</a:t>
-            </a:r>
-          </a:p>
-          <a:p>
-            <a:pPr lvl="1">
-              <a:spcAft>
-                <a:spcPts val="600"/>
-              </a:spcAft>
-            </a:pPr>
-            <a:r>
-              <a:rPr sz="1800">
-                <a:solidFill>
-                  <a:srgbClr val="606060"/>
-                </a:solidFill>
-              </a:rPr>
-              <a:t>–  Handoff — support triage ▶ order / returns / refund</a:t>
-            </a:r>
-          </a:p>
-          <a:p>
-            <a:pPr lvl="1">
-              <a:spcAft>
-                <a:spcPts val="600"/>
-              </a:spcAft>
-            </a:pPr>
-            <a:r>
-              <a:rPr sz="1800">
-                <a:solidFill>
-                  <a:srgbClr val="606060"/>
-                </a:solidFill>
-              </a:rPr>
-              <a:t>–  Magentic — a manager writes a launch brief</a:t>
-            </a:r>
-          </a:p>
-          <a:p>
-            <a:pPr lvl="1">
-              <a:spcAft>
-                <a:spcPts val="600"/>
-              </a:spcAft>
-            </a:pPr>
-            <a:r>
-              <a:rPr sz="1800">
-                <a:solidFill>
-                  <a:srgbClr val="606060"/>
-                </a:solidFill>
-              </a:rPr>
-              <a:t>–  Human-in-the-loop — approve 'publish' before it goes live</a:t>
-            </a:r>
-          </a:p>
-          <a:p>
-            <a:pPr>
-              <a:spcAft>
-                <a:spcPts val="600"/>
-              </a:spcAft>
-            </a:pPr>
-            <a:r>
-              <a:rPr sz="2000">
-                <a:solidFill>
-                  <a:srgbClr val="202020"/>
-                </a:solidFill>
-              </a:rPr>
-              <a:t>•  Traces stream into the Foundry Toolkit as it runs</a:t>
-            </a:r>
-          </a:p>
-        </p:txBody>
-      </p:sp>
-    </p:spTree>
-  </p:cSld>
-  <p:clrMapOvr>
-    <a:masterClrMapping/>
-  </p:clrMapOvr>
-</p:sld>
-</file>
-
-<file path=ppt/slides/slide17.xml><?xml version="1.0" encoding="utf-8"?>
-<p:sld xmlns:a="http://schemas.openxmlformats.org/drawingml/2006/main" xmlns:p="http://schemas.openxmlformats.org/presentationml/2006/main" xmlns:r="http://schemas.openxmlformats.org/officeDocument/2006/relationships">
-  <p:cSld>
-    <p:spTree>
-      <p:nvGrpSpPr>
-        <p:cNvPr id="1" name=""/>
-        <p:cNvGrpSpPr/>
-        <p:nvPr/>
-      </p:nvGrpSpPr>
-      <p:grpSpPr/>
-      <p:sp>
-        <p:nvSpPr>
-          <p:cNvPr id="2" name="Rectangle 1"/>
-          <p:cNvSpPr/>
-          <p:nvPr/>
-        </p:nvSpPr>
-        <p:spPr>
-          <a:xfrm>
-            <a:off x="0" y="0"/>
-            <a:ext cx="12192000" cy="120000"/>
-          </a:xfrm>
-          <a:prstGeom prst="rect">
-            <a:avLst/>
-          </a:prstGeom>
-          <a:solidFill>
-            <a:srgbClr val="0078D4"/>
-          </a:solidFill>
-          <a:ln>
-            <a:noFill/>
-          </a:ln>
-        </p:spPr>
-        <p:style>
-          <a:lnRef idx="1">
-            <a:schemeClr val="accent1"/>
-          </a:lnRef>
-          <a:fillRef idx="3">
-            <a:schemeClr val="accent1"/>
-          </a:fillRef>
-          <a:effectRef idx="2">
-            <a:schemeClr val="accent1"/>
-          </a:effectRef>
-          <a:fontRef idx="minor">
-            <a:schemeClr val="lt1"/>
-          </a:fontRef>
-        </p:style>
-        <p:txBody>
-          <a:bodyPr rtlCol="0" anchor="ctr"/>
-          <a:lstStyle/>
-          <a:p>
-            <a:pPr algn="ctr"/>
-          </a:p>
-        </p:txBody>
-      </p:sp>
-      <p:sp>
-        <p:nvSpPr>
-          <p:cNvPr id="3" name="TextBox 2"/>
-          <p:cNvSpPr txBox="1"/>
-          <p:nvPr/>
-        </p:nvSpPr>
-        <p:spPr>
-          <a:xfrm>
-            <a:off x="600000" y="300000"/>
-            <a:ext cx="11000000" cy="900000"/>
-          </a:xfrm>
-          <a:prstGeom prst="rect">
-            <a:avLst/>
-          </a:prstGeom>
-          <a:noFill/>
-        </p:spPr>
-        <p:txBody>
-          <a:bodyPr wrap="square">
-            <a:spAutoFit/>
-          </a:bodyPr>
-          <a:lstStyle/>
-          <a:p>
-            <a:r>
-              <a:rPr sz="3000" b="1">
-                <a:solidFill>
-                  <a:srgbClr val="202020"/>
-                </a:solidFill>
-              </a:rPr>
-              <a:t>Takeaways</a:t>
-            </a:r>
-          </a:p>
-        </p:txBody>
-      </p:sp>
-      <p:sp>
-        <p:nvSpPr>
-          <p:cNvPr id="4" name="TextBox 3"/>
-          <p:cNvSpPr txBox="1"/>
-          <p:nvPr/>
-        </p:nvSpPr>
-        <p:spPr>
-          <a:xfrm>
-            <a:off x="700000" y="1500000"/>
-            <a:ext cx="10800000" cy="4900000"/>
-          </a:xfrm>
-          <a:prstGeom prst="rect">
-            <a:avLst/>
-          </a:prstGeom>
-          <a:noFill/>
-        </p:spPr>
-        <p:txBody>
-          <a:bodyPr wrap="square">
-            <a:spAutoFit/>
-          </a:bodyPr>
-          <a:lstStyle/>
-          <a:p>
-            <a:pPr>
-              <a:spcAft>
-                <a:spcPts val="600"/>
-              </a:spcAft>
-            </a:pPr>
-            <a:r>
-              <a:rPr sz="2000">
-                <a:solidFill>
-                  <a:srgbClr val="202020"/>
-                </a:solidFill>
-              </a:rPr>
-              <a:t>•  Agents are easy; orchestration was the hard part — now it's building blocks</a:t>
-            </a:r>
-          </a:p>
-          <a:p>
-            <a:pPr>
-              <a:spcAft>
-                <a:spcPts val="600"/>
-              </a:spcAft>
-            </a:pPr>
-            <a:r>
-              <a:rPr sz="2000">
-                <a:solidFill>
-                  <a:srgbClr val="202020"/>
-                </a:solidFill>
-              </a:rPr>
-              <a:t>•  5 stable patterns: Sequential, Concurrent, Handoff, Group Chat, Magentic</a:t>
-            </a:r>
-          </a:p>
-          <a:p>
-            <a:pPr>
-              <a:spcAft>
-                <a:spcPts val="600"/>
-              </a:spcAft>
-            </a:pPr>
-            <a:r>
-              <a:rPr sz="2000">
-                <a:solidFill>
-                  <a:srgbClr val="202020"/>
-                </a:solidFill>
-              </a:rPr>
-              <a:t>•  Human-in-the-loop is a single flag, across every pattern</a:t>
-            </a:r>
-          </a:p>
-          <a:p>
-            <a:pPr>
-              <a:spcAft>
-                <a:spcPts val="600"/>
-              </a:spcAft>
-            </a:pPr>
-            <a:r>
-              <a:rPr sz="2000">
-                <a:solidFill>
-                  <a:srgbClr val="202020"/>
-                </a:solidFill>
-              </a:rPr>
-              <a:t>•  Foundry Toolkit (GA) makes the build→debug→trace→evaluate loop local</a:t>
-            </a:r>
-          </a:p>
-          <a:p>
-            <a:pPr>
-              <a:spcAft>
-                <a:spcPts val="600"/>
-              </a:spcAft>
-            </a:pPr>
-            <a:r>
-              <a:rPr sz="2000">
-                <a:solidFill>
-                  <a:srgbClr val="202020"/>
-                </a:solidFill>
-              </a:rPr>
-              <a:t>•  Same code runs on Azure OpenAI, Foundry, GitHub Models, or OpenAI</a:t>
-            </a:r>
-          </a:p>
-          <a:p>
-            <a:pPr>
-              <a:spcAft>
-                <a:spcPts val="600"/>
-              </a:spcAft>
-            </a:pPr>
-            <a:r>
-              <a:rPr sz="2000">
-                <a:solidFill>
-                  <a:srgbClr val="202020"/>
-                </a:solidFill>
-              </a:rPr>
-              <a:t>•  Start today: pip install agent-framework + install Foundry Toolkit</a:t>
-            </a:r>
-          </a:p>
-        </p:txBody>
-      </p:sp>
-    </p:spTree>
-  </p:cSld>
-  <p:clrMapOvr>
-    <a:masterClrMapping/>
-  </p:clrMapOvr>
-</p:sld>
-</file>
-
-<file path=ppt/slides/slide18.xml><?xml version="1.0" encoding="utf-8"?>
-<p:sld xmlns:a="http://schemas.openxmlformats.org/drawingml/2006/main" xmlns:p="http://schemas.openxmlformats.org/presentationml/2006/main" xmlns:r="http://schemas.openxmlformats.org/officeDocument/2006/relationships">
-  <p:cSld>
-    <p:spTree>
-      <p:nvGrpSpPr>
-        <p:cNvPr id="1" name=""/>
-        <p:cNvGrpSpPr/>
-        <p:nvPr/>
-      </p:nvGrpSpPr>
-      <p:grpSpPr/>
-      <p:sp>
-        <p:nvSpPr>
-          <p:cNvPr id="2" name="Rectangle 1"/>
-          <p:cNvSpPr/>
-          <p:nvPr/>
-        </p:nvSpPr>
-        <p:spPr>
-          <a:xfrm>
-            <a:off x="0" y="0"/>
-            <a:ext cx="12192000" cy="120000"/>
-          </a:xfrm>
-          <a:prstGeom prst="rect">
-            <a:avLst/>
-          </a:prstGeom>
-          <a:solidFill>
-            <a:srgbClr val="0078D4"/>
-          </a:solidFill>
-          <a:ln>
-            <a:noFill/>
-          </a:ln>
-        </p:spPr>
-        <p:style>
-          <a:lnRef idx="1">
-            <a:schemeClr val="accent1"/>
-          </a:lnRef>
-          <a:fillRef idx="3">
-            <a:schemeClr val="accent1"/>
-          </a:fillRef>
-          <a:effectRef idx="2">
-            <a:schemeClr val="accent1"/>
-          </a:effectRef>
-          <a:fontRef idx="minor">
-            <a:schemeClr val="lt1"/>
-          </a:fontRef>
-        </p:style>
-        <p:txBody>
-          <a:bodyPr rtlCol="0" anchor="ctr"/>
-          <a:lstStyle/>
-          <a:p>
-            <a:pPr algn="ctr"/>
-          </a:p>
-        </p:txBody>
-      </p:sp>
-      <p:sp>
-        <p:nvSpPr>
-          <p:cNvPr id="3" name="TextBox 2"/>
-          <p:cNvSpPr txBox="1"/>
-          <p:nvPr/>
-        </p:nvSpPr>
-        <p:spPr>
-          <a:xfrm>
-            <a:off x="600000" y="300000"/>
-            <a:ext cx="11000000" cy="900000"/>
-          </a:xfrm>
-          <a:prstGeom prst="rect">
-            <a:avLst/>
-          </a:prstGeom>
-          <a:noFill/>
-        </p:spPr>
-        <p:txBody>
-          <a:bodyPr wrap="square">
-            <a:spAutoFit/>
-          </a:bodyPr>
-          <a:lstStyle/>
-          <a:p>
-            <a:r>
-              <a:rPr sz="3000" b="1">
-                <a:solidFill>
-                  <a:srgbClr val="202020"/>
-                </a:solidFill>
-              </a:rPr>
-              <a:t>Resources</a:t>
-            </a:r>
-          </a:p>
-        </p:txBody>
-      </p:sp>
-      <p:sp>
-        <p:nvSpPr>
-          <p:cNvPr id="4" name="TextBox 3"/>
-          <p:cNvSpPr txBox="1"/>
-          <p:nvPr/>
-        </p:nvSpPr>
-        <p:spPr>
-          <a:xfrm>
-            <a:off x="700000" y="1500000"/>
-            <a:ext cx="10800000" cy="4900000"/>
-          </a:xfrm>
-          <a:prstGeom prst="rect">
-            <a:avLst/>
-          </a:prstGeom>
-          <a:noFill/>
-        </p:spPr>
-        <p:txBody>
-          <a:bodyPr wrap="square">
-            <a:spAutoFit/>
-          </a:bodyPr>
-          <a:lstStyle/>
-          <a:p>
-            <a:pPr>
-              <a:spcAft>
-                <a:spcPts val="600"/>
-              </a:spcAft>
-            </a:pPr>
-            <a:r>
-              <a:rPr sz="2000">
-                <a:solidFill>
-                  <a:srgbClr val="202020"/>
-                </a:solidFill>
-              </a:rPr>
-              <a:t>•  Microsoft Agent Framework: learn.microsoft.com/agent-framework</a:t>
-            </a:r>
-          </a:p>
-          <a:p>
-            <a:pPr>
-              <a:spcAft>
-                <a:spcPts val="600"/>
-              </a:spcAft>
-            </a:pPr>
-            <a:r>
-              <a:rPr sz="2000">
-                <a:solidFill>
-                  <a:srgbClr val="202020"/>
-                </a:solidFill>
-              </a:rPr>
-              <a:t>•  Orchestrations: learn.microsoft.com/agent-framework/workflows/orchestrations</a:t>
-            </a:r>
-          </a:p>
-          <a:p>
-            <a:pPr>
-              <a:spcAft>
-                <a:spcPts val="600"/>
-              </a:spcAft>
-            </a:pPr>
-            <a:r>
-              <a:rPr sz="2000">
-                <a:solidFill>
-                  <a:srgbClr val="202020"/>
-                </a:solidFill>
-              </a:rPr>
-              <a:t>•  Foundry Toolkit for VS Code: code.visualstudio.com/docs/intelligentapps/overview</a:t>
-            </a:r>
-          </a:p>
-          <a:p>
-            <a:pPr>
-              <a:spcAft>
-                <a:spcPts val="600"/>
-              </a:spcAft>
-            </a:pPr>
-            <a:r>
-              <a:rPr sz="2000">
-                <a:solidFill>
-                  <a:srgbClr val="202020"/>
-                </a:solidFill>
-              </a:rPr>
-              <a:t>•  Install the toolkit: aka.ms/foundrytk</a:t>
-            </a:r>
-          </a:p>
-          <a:p>
-            <a:pPr>
-              <a:spcAft>
-                <a:spcPts val="600"/>
-              </a:spcAft>
-            </a:pPr>
-            <a:r>
-              <a:rPr sz="2000">
-                <a:solidFill>
-                  <a:srgbClr val="202020"/>
-                </a:solidFill>
-              </a:rPr>
-              <a:t>•  This demo repo + slides: &lt;your GitHub URL here&gt;</a:t>
-            </a:r>
-          </a:p>
-          <a:p>
-            <a:pPr>
-              <a:spcAft>
-                <a:spcPts val="600"/>
-              </a:spcAft>
-            </a:pPr>
-            <a:r>
-              <a:rPr sz="2000">
-                <a:solidFill>
-                  <a:srgbClr val="202020"/>
-                </a:solidFill>
-              </a:rPr>
-              <a:t>•  Foundry Agent Service: learn.microsoft.com/azure/ai-foundry</a:t>
-            </a:r>
-          </a:p>
-        </p:txBody>
-      </p:sp>
-    </p:spTree>
-  </p:cSld>
-  <p:clrMapOvr>
-    <a:masterClrMapping/>
-  </p:clrMapOvr>
-</p:sld>
-</file>
-
-<file path=ppt/slides/slide19.xml><?xml version="1.0" encoding="utf-8"?>
-<p:sld xmlns:a="http://schemas.openxmlformats.org/drawingml/2006/main" xmlns:p="http://schemas.openxmlformats.org/presentationml/2006/main" xmlns:r="http://schemas.openxmlformats.org/officeDocument/2006/relationships">
-  <p:cSld>
-    <p:spTree>
-      <p:nvGrpSpPr>
-        <p:cNvPr id="1" name=""/>
-        <p:cNvGrpSpPr/>
-        <p:nvPr/>
-      </p:nvGrpSpPr>
-      <p:grpSpPr/>
-      <p:sp>
-        <p:nvSpPr>
-          <p:cNvPr id="2" name="Rectangle 1"/>
-          <p:cNvSpPr/>
-          <p:nvPr/>
-        </p:nvSpPr>
-        <p:spPr>
-          <a:xfrm>
-            <a:off x="0" y="0"/>
-            <a:ext cx="12192000" cy="6858000"/>
-          </a:xfrm>
-          <a:prstGeom prst="rect">
-            <a:avLst/>
-          </a:prstGeom>
-          <a:solidFill>
-            <a:srgbClr val="0078D4"/>
-          </a:solidFill>
-          <a:ln>
-            <a:noFill/>
-          </a:ln>
-        </p:spPr>
-        <p:style>
-          <a:lnRef idx="1">
-            <a:schemeClr val="accent1"/>
-          </a:lnRef>
-          <a:fillRef idx="3">
-            <a:schemeClr val="accent1"/>
-          </a:fillRef>
-          <a:effectRef idx="2">
-            <a:schemeClr val="accent1"/>
-          </a:effectRef>
-          <a:fontRef idx="minor">
-            <a:schemeClr val="lt1"/>
-          </a:fontRef>
-        </p:style>
-        <p:txBody>
-          <a:bodyPr rtlCol="0" anchor="ctr"/>
-          <a:lstStyle/>
-          <a:p>
-            <a:pPr algn="ctr"/>
-          </a:p>
-        </p:txBody>
-      </p:sp>
-      <p:sp>
-        <p:nvSpPr>
-          <p:cNvPr id="3" name="TextBox 2"/>
-          <p:cNvSpPr txBox="1"/>
-          <p:nvPr/>
-        </p:nvSpPr>
-        <p:spPr>
-          <a:xfrm>
-            <a:off x="700000" y="2200000"/>
-            <a:ext cx="10800000" cy="2000000"/>
-          </a:xfrm>
-          <a:prstGeom prst="rect">
-            <a:avLst/>
-          </a:prstGeom>
-          <a:noFill/>
-        </p:spPr>
-        <p:txBody>
-          <a:bodyPr wrap="square">
-            <a:spAutoFit/>
-          </a:bodyPr>
-          <a:lstStyle/>
-          <a:p>
-            <a:r>
-              <a:rPr sz="4400" b="1">
-                <a:solidFill>
-                  <a:srgbClr val="FFFFFF"/>
-                </a:solidFill>
-              </a:rPr>
-              <a:t>Thank you!</a:t>
-            </a:r>
-          </a:p>
-          <a:p>
-            <a:r>
-              <a:rPr sz="2200">
-                <a:solidFill>
-                  <a:srgbClr val="E8F0FB"/>
-                </a:solidFill>
-              </a:rPr>
-              <a:t>Questions?
-Grab the repo, run `make smoke`, and build an agent today.</a:t>
-            </a:r>
-          </a:p>
-        </p:txBody>
-      </p:sp>
-      <p:sp>
-        <p:nvSpPr>
-          <p:cNvPr id="4" name="TextBox 3"/>
-          <p:cNvSpPr txBox="1"/>
-          <p:nvPr/>
-        </p:nvSpPr>
-        <p:spPr>
-          <a:xfrm>
-            <a:off x="700000" y="5900000"/>
-            <a:ext cx="10800000" cy="500000"/>
-          </a:xfrm>
-          <a:prstGeom prst="rect">
-            <a:avLst/>
-          </a:prstGeom>
-          <a:noFill/>
-        </p:spPr>
-        <p:txBody>
-          <a:bodyPr wrap="square">
-            <a:spAutoFit/>
-          </a:bodyPr>
-          <a:lstStyle/>
-          <a:p>
-            <a:r>
-              <a:rPr sz="1400">
-                <a:solidFill>
-                  <a:srgbClr val="D6E6F7"/>
-                </a:solidFill>
-              </a:rPr>
-              <a:t>Metro Toronto Azure Community · Build 2026 Recap</a:t>
+              <a:t>Foundry Toolkit for VS Code · Build 2026 Recap</a:t>
             </a:r>
           </a:p>
         </p:txBody>
@@ -6943,7 +4763,7 @@
                   <a:srgbClr val="202020"/>
                 </a:solidFill>
               </a:rPr>
-              <a:t>What we'll cover — 25 minutes</a:t>
+              <a:t>What changed at Build (and why this matters)</a:t>
             </a:r>
           </a:p>
         </p:txBody>
@@ -6981,7 +4801,7 @@
                   <a:srgbClr val="202020"/>
                 </a:solidFill>
               </a:rPr>
-              <a:t>•  The problem: agentic apps are mostly orchestration</a:t>
+              <a:t>•  Foundry Toolkit for VS Code is now GA</a:t>
             </a:r>
           </a:p>
           <a:p>
@@ -6996,7 +4816,7 @@
                   <a:srgbClr val="202020"/>
                 </a:solidFill>
               </a:rPr>
-              <a:t>•  Microsoft Agent Framework: successor to Semantic Kernel + AutoGen</a:t>
+              <a:t>•  The full agent dev loop now lives in the editor</a:t>
             </a:r>
           </a:p>
           <a:p>
@@ -7011,7 +4831,7 @@
                   <a:srgbClr val="202020"/>
                 </a:solidFill>
               </a:rPr>
-              <a:t>•  The 5 stable orchestration building blocks (with code)</a:t>
+              <a:t>•  Faster iteration: discover → test → generate → inspect → evaluate</a:t>
             </a:r>
           </a:p>
           <a:p>
@@ -7026,52 +4846,7 @@
                   <a:srgbClr val="202020"/>
                 </a:solidFill>
               </a:rPr>
-              <a:t>•  Human-in-the-loop: approval gates</a:t>
-            </a:r>
-          </a:p>
-          <a:p>
-            <a:pPr>
-              <a:spcAft>
-                <a:spcPts val="600"/>
-              </a:spcAft>
-            </a:pPr>
-            <a:r>
-              <a:rPr sz="2000">
-                <a:solidFill>
-                  <a:srgbClr val="202020"/>
-                </a:solidFill>
-              </a:rPr>
-              <a:t>•  Foundry Toolkit for VS Code (GA): the local dev loop</a:t>
-            </a:r>
-          </a:p>
-          <a:p>
-            <a:pPr>
-              <a:spcAft>
-                <a:spcPts val="600"/>
-              </a:spcAft>
-            </a:pPr>
-            <a:r>
-              <a:rPr sz="2000">
-                <a:solidFill>
-                  <a:srgbClr val="202020"/>
-                </a:solidFill>
-              </a:rPr>
-              <a:t>•  Live demo: 'Contoso Outdoors Launch Desk'</a:t>
-            </a:r>
-          </a:p>
-          <a:p>
-            <a:pPr>
-              <a:spcAft>
-                <a:spcPts val="600"/>
-              </a:spcAft>
-            </a:pPr>
-            <a:r>
-              <a:rPr sz="2000">
-                <a:solidFill>
-                  <a:srgbClr val="202020"/>
-                </a:solidFill>
-              </a:rPr>
-              <a:t>•  Takeaways + resources</a:t>
+              <a:t>•  Lower risk demos and easier onboarding for new teams</a:t>
             </a:r>
           </a:p>
         </p:txBody>
@@ -7165,7 +4940,7 @@
                   <a:srgbClr val="202020"/>
                 </a:solidFill>
               </a:rPr>
-              <a:t>The real problem isn't the model call</a:t>
+              <a:t>Session agenda — 25 minutes</a:t>
             </a:r>
           </a:p>
         </p:txBody>
@@ -7203,52 +4978,7 @@
                   <a:srgbClr val="202020"/>
                 </a:solidFill>
               </a:rPr>
-              <a:t>•  A single model call is easy. Real agents are hard because of orchestration:</a:t>
-            </a:r>
-          </a:p>
-          <a:p>
-            <a:pPr lvl="1">
-              <a:spcAft>
-                <a:spcPts val="600"/>
-              </a:spcAft>
-            </a:pPr>
-            <a:r>
-              <a:rPr sz="1800">
-                <a:solidFill>
-                  <a:srgbClr val="606060"/>
-                </a:solidFill>
-              </a:rPr>
-              <a:t>–  Multiple steps, decisions, tools, and several agents coordinating</a:t>
-            </a:r>
-          </a:p>
-          <a:p>
-            <a:pPr lvl="1">
-              <a:spcAft>
-                <a:spcPts val="600"/>
-              </a:spcAft>
-            </a:pPr>
-            <a:r>
-              <a:rPr sz="1800">
-                <a:solidFill>
-                  <a:srgbClr val="606060"/>
-                </a:solidFill>
-              </a:rPr>
-              <a:t>–  Who runs next? In parallel? Who decides we're done?</a:t>
-            </a:r>
-          </a:p>
-          <a:p>
-            <a:pPr lvl="1">
-              <a:spcAft>
-                <a:spcPts val="600"/>
-              </a:spcAft>
-            </a:pPr>
-            <a:r>
-              <a:rPr sz="1800">
-                <a:solidFill>
-                  <a:srgbClr val="606060"/>
-                </a:solidFill>
-              </a:rPr>
-              <a:t>–  When does a human approve a risky action?</a:t>
+              <a:t>•  What the toolkit is (2-3 min)</a:t>
             </a:r>
           </a:p>
           <a:p>
@@ -7263,7 +4993,7 @@
                   <a:srgbClr val="202020"/>
                 </a:solidFill>
               </a:rPr>
-              <a:t>•  Everyone rebuilds the same coordination plumbing — differently</a:t>
+              <a:t>•  Live loop in VS Code (catalog, playground, builder, inspector)</a:t>
             </a:r>
           </a:p>
           <a:p>
@@ -7278,7 +5008,22 @@
                   <a:srgbClr val="202020"/>
                 </a:solidFill>
               </a:rPr>
-              <a:t>•  Building blocks let you focus on the agents, not the plumbing</a:t>
+              <a:t>•  Tracing + evaluation in the same workflow</a:t>
+            </a:r>
+          </a:p>
+          <a:p>
+            <a:pPr>
+              <a:spcAft>
+                <a:spcPts val="600"/>
+              </a:spcAft>
+            </a:pPr>
+            <a:r>
+              <a:rPr sz="2000">
+                <a:solidFill>
+                  <a:srgbClr val="202020"/>
+                </a:solidFill>
+              </a:rPr>
+              <a:t>•  Practical checklist and fallback plan</a:t>
             </a:r>
           </a:p>
         </p:txBody>
@@ -7310,13 +5055,13 @@
         <p:spPr>
           <a:xfrm>
             <a:off x="0" y="0"/>
-            <a:ext cx="12192000" cy="120000"/>
+            <a:ext cx="12192000" cy="6858000"/>
           </a:xfrm>
           <a:prstGeom prst="rect">
             <a:avLst/>
           </a:prstGeom>
           <a:solidFill>
-            <a:srgbClr val="0078D4"/>
+            <a:srgbClr val="202020"/>
           </a:solidFill>
           <a:ln>
             <a:noFill/>
@@ -7352,8 +5097,8 @@
         </p:nvSpPr>
         <p:spPr>
           <a:xfrm>
-            <a:off x="600000" y="300000"/>
-            <a:ext cx="11000000" cy="900000"/>
+            <a:off x="700000" y="2700000"/>
+            <a:ext cx="10800000" cy="1600000"/>
           </a:xfrm>
           <a:prstGeom prst="rect">
             <a:avLst/>
@@ -7367,140 +5112,22 @@
           <a:lstStyle/>
           <a:p>
             <a:r>
-              <a:rPr sz="3000" b="1">
-                <a:solidFill>
-                  <a:srgbClr val="202020"/>
+              <a:rPr sz="1600" b="1">
+                <a:solidFill>
+                  <a:srgbClr val="0078D4"/>
                 </a:solidFill>
               </a:rPr>
-              <a:t>Microsoft Agent Framework (MAF)</a:t>
-            </a:r>
-          </a:p>
-        </p:txBody>
-      </p:sp>
-      <p:sp>
-        <p:nvSpPr>
-          <p:cNvPr id="4" name="TextBox 3"/>
-          <p:cNvSpPr txBox="1"/>
-          <p:nvPr/>
-        </p:nvSpPr>
-        <p:spPr>
-          <a:xfrm>
-            <a:off x="700000" y="1500000"/>
-            <a:ext cx="10800000" cy="4900000"/>
-          </a:xfrm>
-          <a:prstGeom prst="rect">
-            <a:avLst/>
-          </a:prstGeom>
-          <a:noFill/>
-        </p:spPr>
-        <p:txBody>
-          <a:bodyPr wrap="square">
-            <a:spAutoFit/>
-          </a:bodyPr>
-          <a:lstStyle/>
-          <a:p>
-            <a:pPr>
-              <a:spcAft>
-                <a:spcPts val="600"/>
-              </a:spcAft>
-            </a:pPr>
-            <a:r>
-              <a:rPr sz="2000">
-                <a:solidFill>
-                  <a:srgbClr val="202020"/>
+              <a:t>LIVE WORKFLOW</a:t>
+            </a:r>
+          </a:p>
+          <a:p>
+            <a:r>
+              <a:rPr sz="4000" b="1">
+                <a:solidFill>
+                  <a:srgbClr val="FFFFFF"/>
                 </a:solidFill>
               </a:rPr>
-              <a:t>•  Open-source SDK for agentic systems — Python and .NET</a:t>
-            </a:r>
-          </a:p>
-          <a:p>
-            <a:pPr>
-              <a:spcAft>
-                <a:spcPts val="600"/>
-              </a:spcAft>
-            </a:pPr>
-            <a:r>
-              <a:rPr sz="2000">
-                <a:solidFill>
-                  <a:srgbClr val="202020"/>
-                </a:solidFill>
-              </a:rPr>
-              <a:t>•  The direct successor to Semantic Kernel + AutoGen (same teams)</a:t>
-            </a:r>
-          </a:p>
-          <a:p>
-            <a:pPr lvl="1">
-              <a:spcAft>
-                <a:spcPts val="600"/>
-              </a:spcAft>
-            </a:pPr>
-            <a:r>
-              <a:rPr sz="1800">
-                <a:solidFill>
-                  <a:srgbClr val="606060"/>
-                </a:solidFill>
-              </a:rPr>
-              <a:t>–  AutoGen's simple agent abstractions</a:t>
-            </a:r>
-          </a:p>
-          <a:p>
-            <a:pPr lvl="1">
-              <a:spcAft>
-                <a:spcPts val="600"/>
-              </a:spcAft>
-            </a:pPr>
-            <a:r>
-              <a:rPr sz="1800">
-                <a:solidFill>
-                  <a:srgbClr val="606060"/>
-                </a:solidFill>
-              </a:rPr>
-              <a:t>–  Semantic Kernel's enterprise features: state, type safety, middleware, telemetry</a:t>
-            </a:r>
-          </a:p>
-          <a:p>
-            <a:pPr lvl="1">
-              <a:spcAft>
-                <a:spcPts val="600"/>
-              </a:spcAft>
-            </a:pPr>
-            <a:r>
-              <a:rPr sz="1800">
-                <a:solidFill>
-                  <a:srgbClr val="606060"/>
-                </a:solidFill>
-              </a:rPr>
-              <a:t>–  NEW: graph-based Workflows for explicit multi-agent orchestration</a:t>
-            </a:r>
-          </a:p>
-          <a:p>
-            <a:pPr>
-              <a:spcAft>
-                <a:spcPts val="600"/>
-              </a:spcAft>
-            </a:pPr>
-            <a:r>
-              <a:rPr sz="2000">
-                <a:solidFill>
-                  <a:srgbClr val="202020"/>
-                </a:solidFill>
-              </a:rPr>
-              <a:t>•  An Agent = a model + instructions + tools</a:t>
-            </a:r>
-          </a:p>
-          <a:p>
-            <a:pPr lvl="1">
-              <a:spcAft>
-                <a:spcPts val="600"/>
-              </a:spcAft>
-            </a:pPr>
-            <a:r>
-              <a:rPr sz="1800">
-                <a:solidFill>
-                  <a:srgbClr val="606060"/>
-                </a:solidFill>
-              </a:rPr>
-              <a:t>–  pip install agent-framework</a:t>
+              <a:t>One loop, six toolkit features</a:t>
             </a:r>
           </a:p>
         </p:txBody>
@@ -7575,7 +5202,7 @@
         <p:spPr>
           <a:xfrm>
             <a:off x="600000" y="300000"/>
-            <a:ext cx="11000000" cy="800000"/>
+            <a:ext cx="11000000" cy="900000"/>
           </a:xfrm>
           <a:prstGeom prst="rect">
             <a:avLst/>
@@ -7589,232 +5216,36 @@
           <a:lstStyle/>
           <a:p>
             <a:r>
-              <a:rPr sz="2800" b="1">
+              <a:rPr sz="3000" b="1">
                 <a:solidFill>
                   <a:srgbClr val="202020"/>
                 </a:solidFill>
               </a:rPr>
-              <a:t>An agent is small</a:t>
-            </a:r>
-          </a:p>
-        </p:txBody>
-      </p:sp>
-      <p:sp>
-        <p:nvSpPr>
-          <p:cNvPr id="4" name="Rectangle 3"/>
-          <p:cNvSpPr/>
-          <p:nvPr/>
-        </p:nvSpPr>
-        <p:spPr>
-          <a:xfrm>
-            <a:off x="600000" y="1350000"/>
-            <a:ext cx="11000000" cy="4650000"/>
-          </a:xfrm>
-          <a:prstGeom prst="rect">
-            <a:avLst/>
-          </a:prstGeom>
-          <a:solidFill>
-            <a:srgbClr val="1E1E1E"/>
-          </a:solidFill>
-          <a:ln>
-            <a:noFill/>
-          </a:ln>
-        </p:spPr>
-        <p:style>
-          <a:lnRef idx="1">
-            <a:schemeClr val="accent1"/>
-          </a:lnRef>
-          <a:fillRef idx="3">
-            <a:schemeClr val="accent1"/>
-          </a:fillRef>
-          <a:effectRef idx="2">
-            <a:schemeClr val="accent1"/>
-          </a:effectRef>
-          <a:fontRef idx="minor">
-            <a:schemeClr val="lt1"/>
-          </a:fontRef>
-        </p:style>
-        <p:txBody>
-          <a:bodyPr rtlCol="0" anchor="t" wrap="square" lIns="200000" tIns="150000"/>
-          <a:lstStyle/>
-          <a:p>
-            <a:pPr algn="ctr"/>
-            <a:r>
-              <a:rPr sz="1400">
-                <a:solidFill>
-                  <a:srgbClr val="E6E6E6"/>
-                </a:solidFill>
-                <a:latin typeface="Menlo"/>
+              <a:t>1) Model Catalog</a:t>
+            </a:r>
+          </a:p>
+          <a:p>
+            <a:r>
+              <a:rPr sz="1500" i="1">
+                <a:solidFill>
+                  <a:srgbClr val="606060"/>
+                </a:solidFill>
               </a:rPr>
-              <a:t>from agent_framework import Agent</a:t>
-            </a:r>
-          </a:p>
-          <a:p>
-            <a:r>
-              <a:rPr sz="1400">
-                <a:solidFill>
-                  <a:srgbClr val="E6E6E6"/>
-                </a:solidFill>
-                <a:latin typeface="Menlo"/>
-              </a:rPr>
-              <a:t>from agent_framework.openai import OpenAIChatClient</a:t>
-            </a:r>
-          </a:p>
-          <a:p>
-            <a:r>
-              <a:rPr sz="1400">
-                <a:solidFill>
-                  <a:srgbClr val="E6E6E6"/>
-                </a:solidFill>
-                <a:latin typeface="Menlo"/>
-              </a:rPr>
-              <a:t> </a:t>
-            </a:r>
-          </a:p>
-          <a:p>
-            <a:r>
-              <a:rPr sz="1400">
-                <a:solidFill>
-                  <a:srgbClr val="E6E6E6"/>
-                </a:solidFill>
-                <a:latin typeface="Menlo"/>
-              </a:rPr>
-              <a:t>client = OpenAIChatClient(</a:t>
-            </a:r>
-          </a:p>
-          <a:p>
-            <a:r>
-              <a:rPr sz="1400">
-                <a:solidFill>
-                  <a:srgbClr val="E6E6E6"/>
-                </a:solidFill>
-                <a:latin typeface="Menlo"/>
-              </a:rPr>
-              <a:t>    model="gpt-4o-mini",</a:t>
-            </a:r>
-          </a:p>
-          <a:p>
-            <a:r>
-              <a:rPr sz="1400">
-                <a:solidFill>
-                  <a:srgbClr val="E6E6E6"/>
-                </a:solidFill>
-                <a:latin typeface="Menlo"/>
-              </a:rPr>
-              <a:t>    azure_endpoint="https://&lt;resource&gt;.openai.azure.com",</a:t>
-            </a:r>
-          </a:p>
-          <a:p>
-            <a:r>
-              <a:rPr sz="1400">
-                <a:solidFill>
-                  <a:srgbClr val="E6E6E6"/>
-                </a:solidFill>
-                <a:latin typeface="Menlo"/>
-              </a:rPr>
-              <a:t>    api_version="2024-10-21",</a:t>
-            </a:r>
-          </a:p>
-          <a:p>
-            <a:r>
-              <a:rPr sz="1400">
-                <a:solidFill>
-                  <a:srgbClr val="E6E6E6"/>
-                </a:solidFill>
-                <a:latin typeface="Menlo"/>
-              </a:rPr>
-              <a:t>    credential=AzureCliCredential(),   # or api_key=...</a:t>
-            </a:r>
-          </a:p>
-          <a:p>
-            <a:r>
-              <a:rPr sz="1400">
-                <a:solidFill>
-                  <a:srgbClr val="E6E6E6"/>
-                </a:solidFill>
-                <a:latin typeface="Menlo"/>
-              </a:rPr>
-              <a:t>)</a:t>
-            </a:r>
-          </a:p>
-          <a:p>
-            <a:r>
-              <a:rPr sz="1400">
-                <a:solidFill>
-                  <a:srgbClr val="E6E6E6"/>
-                </a:solidFill>
-                <a:latin typeface="Menlo"/>
-              </a:rPr>
-              <a:t> </a:t>
-            </a:r>
-          </a:p>
-          <a:p>
-            <a:r>
-              <a:rPr sz="1400">
-                <a:solidFill>
-                  <a:srgbClr val="E6E6E6"/>
-                </a:solidFill>
-                <a:latin typeface="Menlo"/>
-              </a:rPr>
-              <a:t>writer = Agent(client=client, name="Writer",</a:t>
-            </a:r>
-          </a:p>
-          <a:p>
-            <a:r>
-              <a:rPr sz="1400">
-                <a:solidFill>
-                  <a:srgbClr val="E6E6E6"/>
-                </a:solidFill>
-                <a:latin typeface="Menlo"/>
-              </a:rPr>
-              <a:t>               instructions="You are a Contoso Outdoors copywriter.")</a:t>
-            </a:r>
-          </a:p>
-          <a:p>
-            <a:r>
-              <a:rPr sz="1400">
-                <a:solidFill>
-                  <a:srgbClr val="E6E6E6"/>
-                </a:solidFill>
-                <a:latin typeface="Menlo"/>
-              </a:rPr>
-              <a:t> </a:t>
-            </a:r>
-          </a:p>
-          <a:p>
-            <a:r>
-              <a:rPr sz="1400">
-                <a:solidFill>
-                  <a:srgbClr val="E6E6E6"/>
-                </a:solidFill>
-                <a:latin typeface="Menlo"/>
-              </a:rPr>
-              <a:t>response = await writer.run("Blurb the Summit backpack.")</a:t>
-            </a:r>
-          </a:p>
-          <a:p>
-            <a:r>
-              <a:rPr sz="1400">
-                <a:solidFill>
-                  <a:srgbClr val="E6E6E6"/>
-                </a:solidFill>
-                <a:latin typeface="Menlo"/>
-              </a:rPr>
-              <a:t>print(response.text)</a:t>
-            </a:r>
-          </a:p>
-        </p:txBody>
-      </p:sp>
-      <p:sp>
-        <p:nvSpPr>
-          <p:cNvPr id="5" name="TextBox 4"/>
+              <a:t>Outcome: model selected for playground + builder</a:t>
+            </a:r>
+          </a:p>
+        </p:txBody>
+      </p:sp>
+      <p:sp>
+        <p:nvSpPr>
+          <p:cNvPr id="4" name="TextBox 3"/>
           <p:cNvSpPr txBox="1"/>
           <p:nvPr/>
         </p:nvSpPr>
         <p:spPr>
           <a:xfrm>
-            <a:off x="600000" y="6150000"/>
-            <a:ext cx="11000000" cy="500000"/>
+            <a:off x="700000" y="1500000"/>
+            <a:ext cx="10800000" cy="4900000"/>
           </a:xfrm>
           <a:prstGeom prst="rect">
             <a:avLst/>
@@ -7827,13 +5258,48 @@
           </a:bodyPr>
           <a:lstStyle/>
           <a:p>
-            <a:r>
-              <a:rPr sz="1300" i="1">
-                <a:solidFill>
-                  <a:srgbClr val="606060"/>
+            <a:pPr>
+              <a:spcAft>
+                <a:spcPts val="600"/>
+              </a:spcAft>
+            </a:pPr>
+            <a:r>
+              <a:rPr sz="2000">
+                <a:solidFill>
+                  <a:srgbClr val="202020"/>
                 </a:solidFill>
               </a:rPr>
-              <a:t>demos/00_single_agent.py — the baseline before orchestration</a:t>
+              <a:t>•  Pick a model you already have access to</a:t>
+            </a:r>
+          </a:p>
+          <a:p>
+            <a:pPr>
+              <a:spcAft>
+                <a:spcPts val="600"/>
+              </a:spcAft>
+            </a:pPr>
+            <a:r>
+              <a:rPr sz="2000">
+                <a:solidFill>
+                  <a:srgbClr val="202020"/>
+                </a:solidFill>
+              </a:rPr>
+              <a:t>•  Explain provider flexibility and model selection criteria</a:t>
+            </a:r>
+          </a:p>
+          <a:p>
+            <a:pPr>
+              <a:spcAft>
+                <a:spcPts val="600"/>
+              </a:spcAft>
+            </a:pPr>
+            <a:r>
+              <a:rPr sz="2000">
+                <a:solidFill>
+                  <a:srgbClr val="202020"/>
+                </a:solidFill>
+              </a:rPr>
+              <a:t>•  Keep this short — goal is to start testing quickly</a:t>
             </a:r>
           </a:p>
         </p:txBody>
@@ -7927,7 +5393,7 @@
                   <a:srgbClr val="202020"/>
                 </a:solidFill>
               </a:rPr>
-              <a:t>The 5 orchestration building blocks</a:t>
+              <a:t>2) Playground</a:t>
             </a:r>
           </a:p>
           <a:p>
@@ -7937,7 +5403,7 @@
                   <a:srgbClr val="606060"/>
                 </a:solidFill>
               </a:rPr>
-              <a:t>from agent_framework.orchestrations import SequentialBuilder, ConcurrentBuilder, HandoffBuilder, GroupChatBuilder, MagenticBuilder</a:t>
+              <a:t>Outcome: prompt validated before coding</a:t>
             </a:r>
           </a:p>
         </p:txBody>
@@ -7975,7 +5441,7 @@
                   <a:srgbClr val="202020"/>
                 </a:solidFill>
               </a:rPr>
-              <a:t>•  Sequential — assembly line; each agent builds on the last</a:t>
+              <a:t>•  Paste prompt from foundry-toolkit/agent-builder-prompt.md</a:t>
             </a:r>
           </a:p>
           <a:p>
@@ -7990,7 +5456,7 @@
                   <a:srgbClr val="202020"/>
                 </a:solidFill>
               </a:rPr>
-              <a:t>•  Concurrent — fan-out/fan-in; run in parallel to cut latency</a:t>
+              <a:t>•  Run a couple prompt variations</a:t>
             </a:r>
           </a:p>
           <a:p>
@@ -8005,52 +5471,7 @@
                   <a:srgbClr val="202020"/>
                 </a:solidFill>
               </a:rPr>
-              <a:t>•  Handoff — route control to the right specialist</a:t>
-            </a:r>
-          </a:p>
-          <a:p>
-            <a:pPr>
-              <a:spcAft>
-                <a:spcPts val="600"/>
-              </a:spcAft>
-            </a:pPr>
-            <a:r>
-              <a:rPr sz="2000">
-                <a:solidFill>
-                  <a:srgbClr val="202020"/>
-                </a:solidFill>
-              </a:rPr>
-              <a:t>•  Group Chat — shared conversation: debate / review / brainstorm</a:t>
-            </a:r>
-          </a:p>
-          <a:p>
-            <a:pPr>
-              <a:spcAft>
-                <a:spcPts val="600"/>
-              </a:spcAft>
-            </a:pPr>
-            <a:r>
-              <a:rPr sz="2000">
-                <a:solidFill>
-                  <a:srgbClr val="202020"/>
-                </a:solidFill>
-              </a:rPr>
-              <a:t>•  Magentic — a manager agent dynamically plans &amp; coordinates</a:t>
-            </a:r>
-          </a:p>
-          <a:p>
-            <a:pPr>
-              <a:spcAft>
-                <a:spcPts val="600"/>
-              </a:spcAft>
-            </a:pPr>
-            <a:r>
-              <a:rPr sz="2000">
-                <a:solidFill>
-                  <a:srgbClr val="202020"/>
-                </a:solidFill>
-              </a:rPr>
-              <a:t>•  All five support human-in-the-loop (approval + request-info)</a:t>
+              <a:t>•  Tune style, tone, and parameters before code generation</a:t>
             </a:r>
           </a:p>
         </p:txBody>
@@ -8125,7 +5546,7 @@
         <p:spPr>
           <a:xfrm>
             <a:off x="600000" y="300000"/>
-            <a:ext cx="11000000" cy="800000"/>
+            <a:ext cx="11000000" cy="900000"/>
           </a:xfrm>
           <a:prstGeom prst="rect">
             <a:avLst/>
@@ -8139,166 +5560,36 @@
           <a:lstStyle/>
           <a:p>
             <a:r>
-              <a:rPr sz="2800" b="1">
+              <a:rPr sz="3000" b="1">
                 <a:solidFill>
                   <a:srgbClr val="202020"/>
                 </a:solidFill>
               </a:rPr>
-              <a:t>1 · Sequential — the pipeline</a:t>
-            </a:r>
-          </a:p>
-        </p:txBody>
-      </p:sp>
-      <p:sp>
-        <p:nvSpPr>
-          <p:cNvPr id="4" name="Rectangle 3"/>
-          <p:cNvSpPr/>
-          <p:nvPr/>
-        </p:nvSpPr>
-        <p:spPr>
-          <a:xfrm>
-            <a:off x="600000" y="1350000"/>
-            <a:ext cx="11000000" cy="4650000"/>
-          </a:xfrm>
-          <a:prstGeom prst="rect">
-            <a:avLst/>
-          </a:prstGeom>
-          <a:solidFill>
-            <a:srgbClr val="1E1E1E"/>
-          </a:solidFill>
-          <a:ln>
-            <a:noFill/>
-          </a:ln>
-        </p:spPr>
-        <p:style>
-          <a:lnRef idx="1">
-            <a:schemeClr val="accent1"/>
-          </a:lnRef>
-          <a:fillRef idx="3">
-            <a:schemeClr val="accent1"/>
-          </a:fillRef>
-          <a:effectRef idx="2">
-            <a:schemeClr val="accent1"/>
-          </a:effectRef>
-          <a:fontRef idx="minor">
-            <a:schemeClr val="lt1"/>
-          </a:fontRef>
-        </p:style>
-        <p:txBody>
-          <a:bodyPr rtlCol="0" anchor="t" wrap="square" lIns="200000" tIns="150000"/>
-          <a:lstStyle/>
-          <a:p>
-            <a:pPr algn="ctr"/>
-            <a:r>
-              <a:rPr sz="1400">
-                <a:solidFill>
-                  <a:srgbClr val="E6E6E6"/>
-                </a:solidFill>
-                <a:latin typeface="Menlo"/>
+              <a:t>3) Agent Builder + 4) Agent Inspector</a:t>
+            </a:r>
+          </a:p>
+          <a:p>
+            <a:r>
+              <a:rPr sz="1500" i="1">
+                <a:solidFill>
+                  <a:srgbClr val="606060"/>
+                </a:solidFill>
               </a:rPr>
-              <a:t>from agent_framework.orchestrations import SequentialBuilder</a:t>
-            </a:r>
-          </a:p>
-          <a:p>
-            <a:r>
-              <a:rPr sz="1400">
-                <a:solidFill>
-                  <a:srgbClr val="E6E6E6"/>
-                </a:solidFill>
-                <a:latin typeface="Menlo"/>
-              </a:rPr>
-              <a:t> </a:t>
-            </a:r>
-          </a:p>
-          <a:p>
-            <a:r>
-              <a:rPr sz="1400">
-                <a:solidFill>
-                  <a:srgbClr val="E6E6E6"/>
-                </a:solidFill>
-                <a:latin typeface="Menlo"/>
-              </a:rPr>
-              <a:t>workflow = SequentialBuilder(</a:t>
-            </a:r>
-          </a:p>
-          <a:p>
-            <a:r>
-              <a:rPr sz="1400">
-                <a:solidFill>
-                  <a:srgbClr val="E6E6E6"/>
-                </a:solidFill>
-                <a:latin typeface="Menlo"/>
-              </a:rPr>
-              <a:t>    participants=[outliner, writer, editor],</a:t>
-            </a:r>
-          </a:p>
-          <a:p>
-            <a:r>
-              <a:rPr sz="1400">
-                <a:solidFill>
-                  <a:srgbClr val="E6E6E6"/>
-                </a:solidFill>
-                <a:latin typeface="Menlo"/>
-              </a:rPr>
-              <a:t>).build()</a:t>
-            </a:r>
-          </a:p>
-          <a:p>
-            <a:r>
-              <a:rPr sz="1400">
-                <a:solidFill>
-                  <a:srgbClr val="E6E6E6"/>
-                </a:solidFill>
-                <a:latin typeface="Menlo"/>
-              </a:rPr>
-              <a:t> </a:t>
-            </a:r>
-          </a:p>
-          <a:p>
-            <a:r>
-              <a:rPr sz="1400">
-                <a:solidFill>
-                  <a:srgbClr val="E6E6E6"/>
-                </a:solidFill>
-                <a:latin typeface="Menlo"/>
-              </a:rPr>
-              <a:t>result = await workflow.run("Choosing your first 3-season tent")</a:t>
-            </a:r>
-          </a:p>
-          <a:p>
-            <a:r>
-              <a:rPr sz="1400">
-                <a:solidFill>
-                  <a:srgbClr val="E6E6E6"/>
-                </a:solidFill>
-                <a:latin typeface="Menlo"/>
-              </a:rPr>
-              <a:t>print(result.get_outputs()[-1])</a:t>
-            </a:r>
-          </a:p>
-          <a:p>
-            <a:r>
-              <a:rPr sz="1400">
-                <a:solidFill>
-                  <a:srgbClr val="E6E6E6"/>
-                </a:solidFill>
-                <a:latin typeface="Menlo"/>
-              </a:rPr>
-              <a:t>#   Outliner ─▶ Writer ─▶ Editor</a:t>
-            </a:r>
-          </a:p>
-        </p:txBody>
-      </p:sp>
-      <p:sp>
-        <p:nvSpPr>
-          <p:cNvPr id="5" name="TextBox 4"/>
+              <a:t>Outcome: prompt becomes runnable code with observability</a:t>
+            </a:r>
+          </a:p>
+        </p:txBody>
+      </p:sp>
+      <p:sp>
+        <p:nvSpPr>
+          <p:cNvPr id="4" name="TextBox 3"/>
           <p:cNvSpPr txBox="1"/>
           <p:nvPr/>
         </p:nvSpPr>
         <p:spPr>
           <a:xfrm>
-            <a:off x="600000" y="6150000"/>
-            <a:ext cx="11000000" cy="500000"/>
+            <a:off x="700000" y="1500000"/>
+            <a:ext cx="10800000" cy="4900000"/>
           </a:xfrm>
           <a:prstGeom prst="rect">
             <a:avLst/>
@@ -8311,13 +5602,48 @@
           </a:bodyPr>
           <a:lstStyle/>
           <a:p>
-            <a:r>
-              <a:rPr sz="1300" i="1">
-                <a:solidFill>
-                  <a:srgbClr val="606060"/>
+            <a:pPr>
+              <a:spcAft>
+                <a:spcPts val="600"/>
+              </a:spcAft>
+            </a:pPr>
+            <a:r>
+              <a:rPr sz="2000">
+                <a:solidFill>
+                  <a:srgbClr val="202020"/>
                 </a:solidFill>
               </a:rPr>
-              <a:t>demos/01_sequential.py — each agent builds on the previous output</a:t>
+              <a:t>•  Generate agent scaffold directly from tested prompt</a:t>
+            </a:r>
+          </a:p>
+          <a:p>
+            <a:pPr>
+              <a:spcAft>
+                <a:spcPts val="600"/>
+              </a:spcAft>
+            </a:pPr>
+            <a:r>
+              <a:rPr sz="2000">
+                <a:solidFill>
+                  <a:srgbClr val="202020"/>
+                </a:solidFill>
+              </a:rPr>
+              <a:t>•  Show generated structure and how to run it locally</a:t>
+            </a:r>
+          </a:p>
+          <a:p>
+            <a:pPr>
+              <a:spcAft>
+                <a:spcPts val="600"/>
+              </a:spcAft>
+            </a:pPr>
+            <a:r>
+              <a:rPr sz="2000">
+                <a:solidFill>
+                  <a:srgbClr val="202020"/>
+                </a:solidFill>
+              </a:rPr>
+              <a:t>•  Use Agent Inspector to visualize turns and debug behavior</a:t>
             </a:r>
           </a:p>
         </p:txBody>
@@ -8411,7 +5737,7 @@
                   <a:srgbClr val="202020"/>
                 </a:solidFill>
               </a:rPr>
-              <a:t>2 · Concurrent — the review board</a:t>
+              <a:t>Run the baseline sample</a:t>
             </a:r>
           </a:p>
         </p:txBody>
@@ -8463,7 +5789,18 @@
                 </a:solidFill>
                 <a:latin typeface="Menlo"/>
               </a:rPr>
-              <a:t>from agent_framework.orchestrations import ConcurrentBuilder</a:t>
+              <a:t>source .venv/bin/activate</a:t>
+            </a:r>
+          </a:p>
+          <a:p>
+            <a:r>
+              <a:rPr sz="1400">
+                <a:solidFill>
+                  <a:srgbClr val="E6E6E6"/>
+                </a:solidFill>
+                <a:latin typeface="Menlo"/>
+              </a:rPr>
+              <a:t>make single</a:t>
             </a:r>
           </a:p>
           <a:p>
@@ -8485,7 +5822,7 @@
                 </a:solidFill>
                 <a:latin typeface="Menlo"/>
               </a:rPr>
-              <a:t>workflow = ConcurrentBuilder(</a:t>
+              <a:t># Optional backend switch in .env</a:t>
             </a:r>
           </a:p>
           <a:p>
@@ -8496,7 +5833,7 @@
                 </a:solidFill>
                 <a:latin typeface="Menlo"/>
               </a:rPr>
-              <a:t>    participants=[seo, legal, brand],   # run in parallel</a:t>
+              <a:t>MODEL_BACKEND=foundry</a:t>
             </a:r>
           </a:p>
           <a:p>
@@ -8507,7 +5844,7 @@
                 </a:solidFill>
                 <a:latin typeface="Menlo"/>
               </a:rPr>
-              <a:t>).build()</a:t>
+              <a:t>FOUNDRY_PROJECT_ENDPOINT=&lt;your-project-endpoint&gt;</a:t>
             </a:r>
           </a:p>
           <a:p>
@@ -8518,51 +5855,7 @@
                 </a:solidFill>
                 <a:latin typeface="Menlo"/>
               </a:rPr>
-              <a:t> </a:t>
-            </a:r>
-          </a:p>
-          <a:p>
-            <a:r>
-              <a:rPr sz="1400">
-                <a:solidFill>
-                  <a:srgbClr val="E6E6E6"/>
-                </a:solidFill>
-                <a:latin typeface="Menlo"/>
-              </a:rPr>
-              <a:t>result = await workflow.run(marketing_copy)</a:t>
-            </a:r>
-          </a:p>
-          <a:p>
-            <a:r>
-              <a:rPr sz="1400">
-                <a:solidFill>
-                  <a:srgbClr val="E6E6E6"/>
-                </a:solidFill>
-                <a:latin typeface="Menlo"/>
-              </a:rPr>
-              <a:t>#        ┌─▶ SEO  ─┐</a:t>
-            </a:r>
-          </a:p>
-          <a:p>
-            <a:r>
-              <a:rPr sz="1400">
-                <a:solidFill>
-                  <a:srgbClr val="E6E6E6"/>
-                </a:solidFill>
-                <a:latin typeface="Menlo"/>
-              </a:rPr>
-              <a:t>#        ├─▶ Legal ┤─▶ aggregated feedback</a:t>
-            </a:r>
-          </a:p>
-          <a:p>
-            <a:r>
-              <a:rPr sz="1400">
-                <a:solidFill>
-                  <a:srgbClr val="E6E6E6"/>
-                </a:solidFill>
-                <a:latin typeface="Menlo"/>
-              </a:rPr>
-              <a:t>#        └─▶ Brand ┘</a:t>
+              <a:t>FOUNDRY_MODEL=&lt;your-model-or-deployment&gt;</a:t>
             </a:r>
           </a:p>
         </p:txBody>
@@ -8595,7 +5888,7 @@
                   <a:srgbClr val="606060"/>
                 </a:solidFill>
               </a:rPr>
-              <a:t>demos/02_concurrent.py — independent tasks in parallel = lower latency</a:t>
+              <a:t>demos/00_single_agent.py is the simplest runtime demo path</a:t>
             </a:r>
           </a:p>
         </p:txBody>
@@ -8689,7 +5982,7 @@
                   <a:srgbClr val="202020"/>
                 </a:solidFill>
               </a:rPr>
-              <a:t>3 · Handoff — route to a specialist</a:t>
+              <a:t>5) Tracing</a:t>
             </a:r>
           </a:p>
         </p:txBody>
@@ -8741,7 +6034,7 @@
                 </a:solidFill>
                 <a:latin typeface="Menlo"/>
               </a:rPr>
-              <a:t>workflow = (</a:t>
+              <a:t># in .env</a:t>
             </a:r>
           </a:p>
           <a:p>
@@ -8752,7 +6045,7 @@
                 </a:solidFill>
                 <a:latin typeface="Menlo"/>
               </a:rPr>
-              <a:t>    HandoffBuilder(name="support",</a:t>
+              <a:t>ENABLE_TRACING=true</a:t>
             </a:r>
           </a:p>
           <a:p>
@@ -8763,7 +6056,7 @@
                 </a:solidFill>
                 <a:latin typeface="Menlo"/>
               </a:rPr>
-              <a:t>                   participants=[triage, orders, returns, refunds],</a:t>
+              <a:t> </a:t>
             </a:r>
           </a:p>
           <a:p>
@@ -8774,7 +6067,7 @@
                 </a:solidFill>
                 <a:latin typeface="Menlo"/>
               </a:rPr>
-              <a:t>                   termination_condition=case_is_closed)</a:t>
+              <a:t># tracing wiring in code</a:t>
             </a:r>
           </a:p>
           <a:p>
@@ -8785,7 +6078,7 @@
                 </a:solidFill>
                 <a:latin typeface="Menlo"/>
               </a:rPr>
-              <a:t>    .with_start_agent(triage)</a:t>
+              <a:t>from agent_framework.observability import configure_otel_providers</a:t>
             </a:r>
           </a:p>
           <a:p>
@@ -8796,7 +6089,7 @@
                 </a:solidFill>
                 <a:latin typeface="Menlo"/>
               </a:rPr>
-              <a:t>    .add_handoff(triage, [orders, returns, refunds])</a:t>
+              <a:t>configure_otel_providers(vs_code_extension_port=4317)</a:t>
             </a:r>
           </a:p>
           <a:p>
@@ -8807,7 +6100,7 @@
                 </a:solidFill>
                 <a:latin typeface="Menlo"/>
               </a:rPr>
-              <a:t>    .add_handoff(returns, [refunds])</a:t>
+              <a:t> </a:t>
             </a:r>
           </a:p>
           <a:p>
@@ -8818,29 +6111,7 @@
                 </a:solidFill>
                 <a:latin typeface="Menlo"/>
               </a:rPr>
-              <a:t>    .build()</a:t>
-            </a:r>
-          </a:p>
-          <a:p>
-            <a:r>
-              <a:rPr sz="1400">
-                <a:solidFill>
-                  <a:srgbClr val="E6E6E6"/>
-                </a:solidFill>
-                <a:latin typeface="Menlo"/>
-              </a:rPr>
-              <a:t>)</a:t>
-            </a:r>
-          </a:p>
-          <a:p>
-            <a:r>
-              <a:rPr sz="1400">
-                <a:solidFill>
-                  <a:srgbClr val="E6E6E6"/>
-                </a:solidFill>
-                <a:latin typeface="Menlo"/>
-              </a:rPr>
-              <a:t>#   triage ─▶ orders / returns ─▶ refunds</a:t>
+              <a:t>make single</a:t>
             </a:r>
           </a:p>
         </p:txBody>
@@ -8873,7 +6144,7 @@
                   <a:srgbClr val="606060"/>
                 </a:solidFill>
               </a:rPr>
-              <a:t>demos/03_handoff.py — triage transfers control based on context</a:t>
+              <a:t>Show spans in Foundry Toolkit Tracing panel after the run</a:t>
             </a:r>
           </a:p>
         </p:txBody>

</xml_diff>